<commit_message>
feat: integrate Phase 2 pipeline into Phase 3 and stabilize forecasting backbone
- Added joblib export of fitted Phase 2 pipeline (phase2_v4_best_pipeline.joblib)
- Updated Phase 3 to load Phase 2 pipeline artifact instead of reconstructing model
- Fixed file path to use phase2_outputs_v4 directory
- Aligned Phase 3 backbone evaluation with Phase 2 split logic
- Resolved feature consistency issues affecting model performance
- Fixed municipal vulnerability vs baseline percent impact calculation
- Improved plotting robustness (OUTDIR handling)

Result: validated forecasting backbone with improved performance and reduced model drift across phases
</commit_message>
<xml_diff>
--- a/project_reports/Week10_progress.pptx
+++ b/project_reports/Week10_progress.pptx
@@ -62,7 +62,7 @@
       <p:boldItalic r:id="rId40"/>
     </p:embeddedFont>
     <p:embeddedFont>
-      <p:font typeface="Source sans 3" panose="020B0303030403020204" pitchFamily="34" charset="0"/>
+      <p:font typeface="Source sans 3" panose="020B0303030403020204"/>
       <p:regular r:id="rId41"/>
       <p:bold r:id="rId42"/>
       <p:italic r:id="rId43"/>
@@ -2349,15 +2349,7 @@
           <a:p>
             <a:r>
               <a:rPr lang="en-US" dirty="0"/>
-              <a:t>The project uses both supervised and unsupervised methods. Supervised models such as Random </a:t>
-            </a:r>
-            <a:r>
-              <a:rPr lang="en-US" dirty="0" err="1"/>
-              <a:t>Forestand</a:t>
-            </a:r>
-            <a:r>
-              <a:rPr lang="en-US" dirty="0"/>
-              <a:t> Lasso  are used to predict population change. Unsupervised methods, including K-Means and hierarchical clustering, are then used to identify structural municipal typologies based on socioeconomic and environmental characteristics.</a:t>
+              <a:t>The project uses both supervised and unsupervised methods. Supervised models such as Random Forest and Lasso  are used to predict population change. Unsupervised methods, including K-Means and hierarchical clustering, are then used to identify structural municipal typologies based on socioeconomic and environmental characteristics.</a:t>
             </a:r>
           </a:p>
           <a:p>
@@ -7903,7 +7895,7 @@
                 <a:cs typeface="Arial" panose="020B0604020202020204" pitchFamily="34" charset="0"/>
                 <a:sym typeface="DM Sans"/>
               </a:rPr>
-              <a:t>Week 8-9 Progress: 27 March 2026</a:t>
+              <a:t>Week 10 Progress: 3 April 2026</a:t>
             </a:r>
             <a:endParaRPr lang="en-US" sz="1400" b="1" dirty="0">
               <a:latin typeface="+mj-lt"/>
@@ -17516,7 +17508,7 @@
           <p:spPr>
             <a:xfrm>
               <a:off x="3785731" y="2136371"/>
-              <a:ext cx="1645442" cy="2400657"/>
+              <a:ext cx="1645442" cy="2246769"/>
             </a:xfrm>
             <a:prstGeom prst="rect">
               <a:avLst/>
@@ -17550,15 +17542,7 @@
               </a:pPr>
               <a:r>
                 <a:rPr lang="en-US" sz="1000" dirty="0"/>
-                <a:t>Lasso Regression (</a:t>
-              </a:r>
-              <a:r>
-                <a:rPr lang="en-US" sz="1000" b="1" dirty="0"/>
-                <a:t>selected model</a:t>
-              </a:r>
-              <a:r>
-                <a:rPr lang="en-US" sz="1000" dirty="0"/>
-                <a:t>) </a:t>
+                <a:t>Extra Trees regression</a:t>
               </a:r>
             </a:p>
             <a:p>
@@ -18681,7 +18665,7 @@
                   <a:schemeClr val="bg1"/>
                 </a:solidFill>
               </a:rPr>
-              <a:t>Model v1: Lasso Regression </a:t>
+              <a:t>Model Selection</a:t>
             </a:r>
           </a:p>
         </p:txBody>
@@ -19044,7 +19028,7 @@
         <p:spPr>
           <a:xfrm>
             <a:off x="139613" y="1368962"/>
-            <a:ext cx="9560053" cy="3016210"/>
+            <a:ext cx="9560053" cy="3970318"/>
           </a:xfrm>
           <a:prstGeom prst="rect">
             <a:avLst/>
@@ -19061,6 +19045,7 @@
               <a:rPr lang="en-US" b="1" dirty="0"/>
               <a:t>Results</a:t>
             </a:r>
+            <a:endParaRPr lang="en-US" dirty="0"/>
           </a:p>
           <a:p>
             <a:pPr marL="285750" indent="-285750">
@@ -19068,157 +19053,102 @@
               <a:buChar char="•"/>
             </a:pPr>
             <a:r>
-              <a:rPr lang="en-US" altLang="en-US" sz="1600" dirty="0"/>
-              <a:t>Initial linear models exhibited </a:t>
-            </a:r>
-            <a:r>
-              <a:rPr lang="en-US" altLang="en-US" sz="1600" b="1" dirty="0"/>
-              <a:t>negative out-of-sample R²</a:t>
-            </a:r>
-            <a:r>
-              <a:rPr lang="en-US" altLang="en-US" sz="1600" dirty="0"/>
-              <a:t> </a:t>
-            </a:r>
-          </a:p>
-          <a:p>
-            <a:pPr marL="285750" lvl="0" indent="-285750" eaLnBrk="0" fontAlgn="base" hangingPunct="0">
-              <a:spcBef>
-                <a:spcPct val="0"/>
-              </a:spcBef>
-              <a:spcAft>
-                <a:spcPct val="0"/>
-              </a:spcAft>
+              <a:rPr lang="en-US" dirty="0"/>
+              <a:t>Initial linear models exhibited negative out-of-sample R² </a:t>
+            </a:r>
+          </a:p>
+          <a:p>
+            <a:pPr marL="285750" indent="-285750">
               <a:buFont typeface="Arial" panose="020B0604020202020204" pitchFamily="34" charset="0"/>
               <a:buChar char="•"/>
             </a:pPr>
             <a:r>
-              <a:rPr lang="en-US" altLang="en-US" sz="1600" dirty="0"/>
+              <a:rPr lang="en-US" dirty="0"/>
               <a:t>Transition to nonlinear models significantly improved performance </a:t>
             </a:r>
           </a:p>
           <a:p>
-            <a:pPr marL="285750" lvl="0" indent="-285750" eaLnBrk="0" fontAlgn="base" hangingPunct="0">
-              <a:spcBef>
-                <a:spcPct val="0"/>
-              </a:spcBef>
-              <a:spcAft>
-                <a:spcPct val="0"/>
-              </a:spcAft>
+            <a:pPr marL="285750" indent="-285750">
               <a:buFont typeface="Arial" panose="020B0604020202020204" pitchFamily="34" charset="0"/>
               <a:buChar char="•"/>
             </a:pPr>
             <a:r>
-              <a:rPr lang="en-US" altLang="en-US" sz="1600" b="1" dirty="0"/>
-              <a:t>Extra Trees achieved positive predictive power</a:t>
-            </a:r>
-            <a:r>
-              <a:rPr lang="en-US" altLang="en-US" sz="1600" dirty="0"/>
-              <a:t> </a:t>
-            </a:r>
-          </a:p>
-          <a:p>
-            <a:pPr marL="285750" lvl="0" indent="-285750" eaLnBrk="0" fontAlgn="base" hangingPunct="0">
-              <a:spcBef>
-                <a:spcPct val="0"/>
-              </a:spcBef>
-              <a:spcAft>
-                <a:spcPct val="0"/>
-              </a:spcAft>
+              <a:rPr lang="en-US" dirty="0"/>
+              <a:t>Extra Trees achieved stable and improved predictive power </a:t>
+            </a:r>
+          </a:p>
+          <a:p>
+            <a:pPr marL="285750" indent="-285750">
               <a:buFont typeface="Arial" panose="020B0604020202020204" pitchFamily="34" charset="0"/>
               <a:buChar char="•"/>
             </a:pPr>
             <a:r>
-              <a:rPr lang="en-US" altLang="en-US" sz="1600" dirty="0"/>
-              <a:t>3-year forward target remains critical for stability</a:t>
-            </a:r>
-            <a:br>
-              <a:rPr lang="en-US" dirty="0"/>
-            </a:br>
-            <a:endParaRPr lang="en-US" dirty="0"/>
-          </a:p>
-          <a:p>
-            <a:r>
-              <a:rPr lang="en-US" b="1" dirty="0"/>
-              <a:t>Interpretation: </a:t>
-            </a:r>
-            <a:r>
-              <a:rPr lang="en-US" dirty="0"/>
-              <a:t>Population change is a </a:t>
-            </a:r>
-            <a:r>
-              <a:rPr lang="en-US" b="1" dirty="0"/>
-              <a:t>high-noise outcome</a:t>
-            </a:r>
-            <a:endParaRPr lang="en-US" dirty="0"/>
-          </a:p>
-          <a:p>
-            <a:pPr marL="285750" lvl="0" indent="-285750" eaLnBrk="0" fontAlgn="base" hangingPunct="0">
-              <a:spcBef>
-                <a:spcPct val="0"/>
-              </a:spcBef>
-              <a:spcAft>
-                <a:spcPct val="0"/>
-              </a:spcAft>
+              <a:rPr lang="en-US" dirty="0"/>
+              <a:t>Phase 3 improved Test R² from ~0.17 → ~0.23 </a:t>
+            </a:r>
+          </a:p>
+          <a:p>
+            <a:pPr marL="285750" indent="-285750">
               <a:buFont typeface="Arial" panose="020B0604020202020204" pitchFamily="34" charset="0"/>
               <a:buChar char="•"/>
             </a:pPr>
             <a:r>
-              <a:rPr lang="en-US" altLang="en-US" sz="1600" dirty="0"/>
-              <a:t>Nonlinear models capture </a:t>
-            </a:r>
-            <a:r>
-              <a:rPr lang="en-US" altLang="en-US" sz="1600" b="1" dirty="0"/>
-              <a:t>hidden structure</a:t>
-            </a:r>
-            <a:r>
-              <a:rPr lang="en-US" altLang="en-US" sz="1600" dirty="0"/>
-              <a:t> </a:t>
-            </a:r>
-          </a:p>
-          <a:p>
-            <a:pPr marL="285750" lvl="0" indent="-285750" eaLnBrk="0" fontAlgn="base" hangingPunct="0">
-              <a:spcBef>
-                <a:spcPct val="0"/>
-              </a:spcBef>
-              <a:spcAft>
-                <a:spcPct val="0"/>
-              </a:spcAft>
+              <a:rPr lang="en-US" dirty="0"/>
+              <a:t>3-year forward target remains critical for stability </a:t>
+            </a:r>
+          </a:p>
+          <a:p>
+            <a:br>
+              <a:rPr lang="en-US" dirty="0"/>
+            </a:br>
+            <a:endParaRPr lang="en-US" dirty="0"/>
+          </a:p>
+          <a:p>
+            <a:r>
+              <a:rPr lang="en-US" b="1" dirty="0"/>
+              <a:t>Interpretation</a:t>
+            </a:r>
+            <a:endParaRPr lang="en-US" dirty="0"/>
+          </a:p>
+          <a:p>
+            <a:pPr marL="285750" indent="-285750">
               <a:buFont typeface="Arial" panose="020B0604020202020204" pitchFamily="34" charset="0"/>
               <a:buChar char="•"/>
             </a:pPr>
             <a:r>
-              <a:rPr lang="en-US" altLang="en-US" sz="1600" dirty="0"/>
-              <a:t>Structural + disaster features provide </a:t>
-            </a:r>
-            <a:r>
-              <a:rPr lang="en-US" altLang="en-US" sz="1600" b="1" dirty="0"/>
-              <a:t>meaningful signal</a:t>
-            </a:r>
-            <a:r>
-              <a:rPr lang="en-US" altLang="en-US" sz="1600" dirty="0"/>
-              <a:t> </a:t>
-            </a:r>
-          </a:p>
-          <a:p>
-            <a:pPr marL="285750" lvl="0" indent="-285750" eaLnBrk="0" fontAlgn="base" hangingPunct="0">
-              <a:spcBef>
-                <a:spcPct val="0"/>
-              </a:spcBef>
-              <a:spcAft>
-                <a:spcPct val="0"/>
-              </a:spcAft>
+              <a:rPr lang="en-US" dirty="0"/>
+              <a:t>Population change is a high-noise but structured outcome </a:t>
+            </a:r>
+          </a:p>
+          <a:p>
+            <a:pPr marL="285750" indent="-285750">
               <a:buFont typeface="Arial" panose="020B0604020202020204" pitchFamily="34" charset="0"/>
               <a:buChar char="•"/>
             </a:pPr>
             <a:r>
-              <a:rPr lang="en-US" altLang="en-US" sz="1600" dirty="0"/>
-              <a:t>Prediction improves when focusing on </a:t>
-            </a:r>
-            <a:r>
-              <a:rPr lang="en-US" altLang="en-US" sz="1600" b="1" dirty="0"/>
-              <a:t>long-term dynamics (3-year target)</a:t>
-            </a:r>
-            <a:endParaRPr lang="en-US" altLang="en-US" sz="1600" dirty="0"/>
+              <a:rPr lang="en-US" dirty="0"/>
+              <a:t>Nonlinear models capture hidden structure </a:t>
+            </a:r>
+          </a:p>
+          <a:p>
+            <a:pPr marL="285750" indent="-285750">
+              <a:buFont typeface="Arial" panose="020B0604020202020204" pitchFamily="34" charset="0"/>
+              <a:buChar char="•"/>
+            </a:pPr>
+            <a:r>
+              <a:rPr lang="en-US" dirty="0"/>
+              <a:t>Structural + disaster features provide meaningful signal </a:t>
+            </a:r>
+          </a:p>
+          <a:p>
+            <a:pPr marL="285750" indent="-285750">
+              <a:buFont typeface="Arial" panose="020B0604020202020204" pitchFamily="34" charset="0"/>
+              <a:buChar char="•"/>
+            </a:pPr>
+            <a:r>
+              <a:rPr lang="en-US" dirty="0"/>
+              <a:t>Model performance is now stable and validated across phases </a:t>
+            </a:r>
           </a:p>
           <a:p>
             <a:pPr marL="285750" indent="-285750">
@@ -19231,10 +19161,10 @@
       </p:sp>
       <p:pic>
         <p:nvPicPr>
-          <p:cNvPr id="8" name="Picture 7">
+          <p:cNvPr id="3" name="Picture 2">
             <a:extLst>
               <a:ext uri="{FF2B5EF4-FFF2-40B4-BE49-F238E27FC236}">
-                <a16:creationId xmlns:a16="http://schemas.microsoft.com/office/drawing/2014/main" id="{7D61AEBD-712C-863D-6977-5F29EE625596}"/>
+                <a16:creationId xmlns:a16="http://schemas.microsoft.com/office/drawing/2014/main" id="{7952A3C0-276D-663C-7A79-F564C77004A4}"/>
               </a:ext>
             </a:extLst>
           </p:cNvPr>
@@ -19257,12 +19187,17 @@
         </p:blipFill>
         <p:spPr>
           <a:xfrm>
-            <a:off x="459357" y="4071317"/>
-            <a:ext cx="4867553" cy="2059349"/>
+            <a:off x="6899361" y="3429000"/>
+            <a:ext cx="5304996" cy="2599938"/>
           </a:xfrm>
           <a:prstGeom prst="rect">
             <a:avLst/>
           </a:prstGeom>
+          <a:ln>
+            <a:solidFill>
+              <a:schemeClr val="tx1"/>
+            </a:solidFill>
+          </a:ln>
         </p:spPr>
       </p:pic>
     </p:spTree>
@@ -21459,6 +21394,14 @@
 </file>
 
 <file path=customXml/item1.xml><?xml version="1.0" encoding="utf-8"?>
+<p:properties xmlns:p="http://schemas.microsoft.com/office/2006/metadata/properties" xmlns:xsi="http://www.w3.org/2001/XMLSchema-instance" xmlns:pc="http://schemas.microsoft.com/office/infopath/2007/PartnerControls">
+  <documentManagement>
+    <_activity xmlns="11e45801-bee2-4eee-abb6-7fc01a896634" xsi:nil="true"/>
+  </documentManagement>
+</p:properties>
+</file>
+
+<file path=customXml/item2.xml><?xml version="1.0" encoding="utf-8"?>
 <ct:contentTypeSchema xmlns:ct="http://schemas.microsoft.com/office/2006/metadata/contentType" xmlns:ma="http://schemas.microsoft.com/office/2006/metadata/properties/metaAttributes" ct:_="" ma:_="" ma:contentTypeName="Document" ma:contentTypeID="0x01010015021A5DC4BEF54E90B3A7E0D30B82FD" ma:contentTypeVersion="5" ma:contentTypeDescription="Create a new document." ma:contentTypeScope="" ma:versionID="0b09cb170d6a15113edb6f479f6ecd10">
   <xsd:schema xmlns:xsd="http://www.w3.org/2001/XMLSchema" xmlns:xs="http://www.w3.org/2001/XMLSchema" xmlns:p="http://schemas.microsoft.com/office/2006/metadata/properties" xmlns:ns3="11e45801-bee2-4eee-abb6-7fc01a896634" targetNamespace="http://schemas.microsoft.com/office/2006/metadata/properties" ma:root="true" ma:fieldsID="c9b1b393770a16940206f9bb69539431" ns3:_="">
     <xsd:import namespace="11e45801-bee2-4eee-abb6-7fc01a896634"/>
@@ -21608,7 +21551,7 @@
 </ct:contentTypeSchema>
 </file>
 
-<file path=customXml/item2.xml><?xml version="1.0" encoding="utf-8"?>
+<file path=customXml/item3.xml><?xml version="1.0" encoding="utf-8"?>
 <?mso-contentType ?>
 <FormTemplates xmlns="http://schemas.microsoft.com/sharepoint/v3/contenttype/forms">
   <Display>DocumentLibraryForm</Display>
@@ -21617,15 +21560,23 @@
 </FormTemplates>
 </file>
 
-<file path=customXml/item3.xml><?xml version="1.0" encoding="utf-8"?>
-<p:properties xmlns:p="http://schemas.microsoft.com/office/2006/metadata/properties" xmlns:xsi="http://www.w3.org/2001/XMLSchema-instance" xmlns:pc="http://schemas.microsoft.com/office/infopath/2007/PartnerControls">
-  <documentManagement>
-    <_activity xmlns="11e45801-bee2-4eee-abb6-7fc01a896634" xsi:nil="true"/>
-  </documentManagement>
-</p:properties>
+<file path=customXml/itemProps1.xml><?xml version="1.0" encoding="utf-8"?>
+<ds:datastoreItem xmlns:ds="http://schemas.openxmlformats.org/officeDocument/2006/customXml" ds:itemID="{1EFFF01E-6DF4-4530-B663-FF4BD91444A6}">
+  <ds:schemaRefs>
+    <ds:schemaRef ds:uri="11e45801-bee2-4eee-abb6-7fc01a896634"/>
+    <ds:schemaRef ds:uri="http://schemas.microsoft.com/office/2006/documentManagement/types"/>
+    <ds:schemaRef ds:uri="http://www.w3.org/XML/1998/namespace"/>
+    <ds:schemaRef ds:uri="http://schemas.microsoft.com/office/2006/metadata/properties"/>
+    <ds:schemaRef ds:uri="http://purl.org/dc/terms/"/>
+    <ds:schemaRef ds:uri="http://purl.org/dc/elements/1.1/"/>
+    <ds:schemaRef ds:uri="http://schemas.microsoft.com/office/infopath/2007/PartnerControls"/>
+    <ds:schemaRef ds:uri="http://schemas.openxmlformats.org/package/2006/metadata/core-properties"/>
+    <ds:schemaRef ds:uri="http://purl.org/dc/dcmitype/"/>
+  </ds:schemaRefs>
+</ds:datastoreItem>
 </file>
 
-<file path=customXml/itemProps1.xml><?xml version="1.0" encoding="utf-8"?>
+<file path=customXml/itemProps2.xml><?xml version="1.0" encoding="utf-8"?>
 <ds:datastoreItem xmlns:ds="http://schemas.openxmlformats.org/officeDocument/2006/customXml" ds:itemID="{CB7AAD6B-2CD1-4FD9-A228-72630DF2E75E}">
   <ds:schemaRefs>
     <ds:schemaRef ds:uri="http://schemas.microsoft.com/office/2006/metadata/contentType"/>
@@ -21643,26 +21594,10 @@
 </ds:datastoreItem>
 </file>
 
-<file path=customXml/itemProps2.xml><?xml version="1.0" encoding="utf-8"?>
+<file path=customXml/itemProps3.xml><?xml version="1.0" encoding="utf-8"?>
 <ds:datastoreItem xmlns:ds="http://schemas.openxmlformats.org/officeDocument/2006/customXml" ds:itemID="{B94EBF72-05B3-4092-B058-100DE54983B2}">
   <ds:schemaRefs>
     <ds:schemaRef ds:uri="http://schemas.microsoft.com/sharepoint/v3/contenttype/forms"/>
   </ds:schemaRefs>
 </ds:datastoreItem>
-</file>
-
-<file path=customXml/itemProps3.xml><?xml version="1.0" encoding="utf-8"?>
-<ds:datastoreItem xmlns:ds="http://schemas.openxmlformats.org/officeDocument/2006/customXml" ds:itemID="{1EFFF01E-6DF4-4530-B663-FF4BD91444A6}">
-  <ds:schemaRefs>
-    <ds:schemaRef ds:uri="11e45801-bee2-4eee-abb6-7fc01a896634"/>
-    <ds:schemaRef ds:uri="http://schemas.microsoft.com/office/2006/documentManagement/types"/>
-    <ds:schemaRef ds:uri="http://www.w3.org/XML/1998/namespace"/>
-    <ds:schemaRef ds:uri="http://schemas.microsoft.com/office/2006/metadata/properties"/>
-    <ds:schemaRef ds:uri="http://purl.org/dc/terms/"/>
-    <ds:schemaRef ds:uri="http://purl.org/dc/elements/1.1/"/>
-    <ds:schemaRef ds:uri="http://schemas.microsoft.com/office/infopath/2007/PartnerControls"/>
-    <ds:schemaRef ds:uri="http://schemas.openxmlformats.org/package/2006/metadata/core-properties"/>
-    <ds:schemaRef ds:uri="http://purl.org/dc/dcmitype/"/>
-  </ds:schemaRefs>
-</ds:datastoreItem>
 </file>
</xml_diff>

<commit_message>
feat: add lead-lag analysis and align Phase 2–3 modeling insights
- Implement lead–lag (tornado-style) analysis in Phase 2 using permutation importance
- Add lagged features for disaster, socioeconomic, and vulnerability variables
- Fix masking and feature alignment issues in lead–lag modeling pipeline
- Resolve permutation importance length mismatch and ensure correct feature naming
- Generate lead–lag tornado plot and export results to phase2_outputs_v4

- Align SHAP and lead–lag interpretation to explain both driver importance and timing
- Update Phase 2 conclusion to incorporate temporal dynamics and delayed effects
- Update Phase 3 conclusion to reflect improved model performance and validated backbone
- Improve narrative consistency across modeling, interpretation, and forecasting phases

Result: coherent framework explaining what drives population change and when effects occur
</commit_message>
<xml_diff>
--- a/project_reports/Week10_progress.pptx
+++ b/project_reports/Week10_progress.pptx
@@ -5,10 +5,10 @@
     <p:sldMasterId id="2147483661" r:id="rId4"/>
   </p:sldMasterIdLst>
   <p:notesMasterIdLst>
-    <p:notesMasterId r:id="rId26"/>
+    <p:notesMasterId r:id="rId27"/>
   </p:notesMasterIdLst>
   <p:handoutMasterIdLst>
-    <p:handoutMasterId r:id="rId27"/>
+    <p:handoutMasterId r:id="rId28"/>
   </p:handoutMasterIdLst>
   <p:sldIdLst>
     <p:sldId id="408" r:id="rId5"/>
@@ -17,56 +17,57 @@
     <p:sldId id="431" r:id="rId8"/>
     <p:sldId id="432" r:id="rId9"/>
     <p:sldId id="440" r:id="rId10"/>
-    <p:sldId id="434" r:id="rId11"/>
-    <p:sldId id="435" r:id="rId12"/>
-    <p:sldId id="436" r:id="rId13"/>
-    <p:sldId id="437" r:id="rId14"/>
-    <p:sldId id="441" r:id="rId15"/>
-    <p:sldId id="438" r:id="rId16"/>
-    <p:sldId id="439" r:id="rId17"/>
-    <p:sldId id="430" r:id="rId18"/>
-    <p:sldId id="273" r:id="rId19"/>
-    <p:sldId id="442" r:id="rId20"/>
-    <p:sldId id="275" r:id="rId21"/>
-    <p:sldId id="276" r:id="rId22"/>
-    <p:sldId id="277" r:id="rId23"/>
-    <p:sldId id="279" r:id="rId24"/>
-    <p:sldId id="281" r:id="rId25"/>
+    <p:sldId id="443" r:id="rId11"/>
+    <p:sldId id="434" r:id="rId12"/>
+    <p:sldId id="435" r:id="rId13"/>
+    <p:sldId id="436" r:id="rId14"/>
+    <p:sldId id="437" r:id="rId15"/>
+    <p:sldId id="441" r:id="rId16"/>
+    <p:sldId id="438" r:id="rId17"/>
+    <p:sldId id="439" r:id="rId18"/>
+    <p:sldId id="430" r:id="rId19"/>
+    <p:sldId id="273" r:id="rId20"/>
+    <p:sldId id="442" r:id="rId21"/>
+    <p:sldId id="275" r:id="rId22"/>
+    <p:sldId id="276" r:id="rId23"/>
+    <p:sldId id="277" r:id="rId24"/>
+    <p:sldId id="279" r:id="rId25"/>
+    <p:sldId id="281" r:id="rId26"/>
   </p:sldIdLst>
   <p:sldSz cx="12192000" cy="6858000"/>
   <p:notesSz cx="9296400" cy="7010400"/>
   <p:embeddedFontLst>
     <p:embeddedFont>
       <p:font typeface="Cambria Math" panose="02040503050406030204" pitchFamily="18" charset="0"/>
-      <p:regular r:id="rId28"/>
+      <p:regular r:id="rId29"/>
     </p:embeddedFont>
     <p:embeddedFont>
       <p:font typeface="Merriweather" pitchFamily="2" charset="77"/>
-      <p:regular r:id="rId29"/>
-      <p:bold r:id="rId30"/>
-      <p:italic r:id="rId31"/>
-      <p:boldItalic r:id="rId32"/>
+      <p:regular r:id="rId30"/>
+      <p:bold r:id="rId31"/>
+      <p:italic r:id="rId32"/>
+      <p:boldItalic r:id="rId33"/>
     </p:embeddedFont>
     <p:embeddedFont>
       <p:font typeface="PT serif" panose="020A0603040505020204" pitchFamily="18" charset="77"/>
-      <p:regular r:id="rId33"/>
-      <p:bold r:id="rId34"/>
-      <p:italic r:id="rId35"/>
-      <p:boldItalic r:id="rId36"/>
+      <p:regular r:id="rId34"/>
+      <p:bold r:id="rId35"/>
+      <p:italic r:id="rId36"/>
+      <p:boldItalic r:id="rId37"/>
     </p:embeddedFont>
     <p:embeddedFont>
       <p:font typeface="Roboto" panose="02000000000000000000" pitchFamily="2" charset="0"/>
-      <p:regular r:id="rId37"/>
-      <p:bold r:id="rId38"/>
-      <p:italic r:id="rId39"/>
-      <p:boldItalic r:id="rId40"/>
+      <p:regular r:id="rId38"/>
+      <p:bold r:id="rId39"/>
+      <p:italic r:id="rId40"/>
+      <p:boldItalic r:id="rId41"/>
     </p:embeddedFont>
     <p:embeddedFont>
       <p:font typeface="Source sans 3" panose="020B0303030403020204"/>
-      <p:regular r:id="rId41"/>
-      <p:bold r:id="rId42"/>
-      <p:italic r:id="rId43"/>
-      <p:boldItalic r:id="rId44"/>
+      <p:regular r:id="rId42"/>
+      <p:bold r:id="rId43"/>
+      <p:italic r:id="rId44"/>
+      <p:boldItalic r:id="rId45"/>
     </p:embeddedFont>
   </p:embeddedFontLst>
   <p:defaultTextStyle>
@@ -873,6 +874,114 @@
 </file>
 
 <file path=ppt/notesSlides/notesSlide10.xml><?xml version="1.0" encoding="utf-8"?>
+<p:notes xmlns:a="http://schemas.openxmlformats.org/drawingml/2006/main" xmlns:r="http://schemas.openxmlformats.org/officeDocument/2006/relationships" xmlns:p="http://schemas.openxmlformats.org/presentationml/2006/main">
+  <p:cSld>
+    <p:spTree>
+      <p:nvGrpSpPr>
+        <p:cNvPr id="1" name="">
+          <a:extLst>
+            <a:ext uri="{FF2B5EF4-FFF2-40B4-BE49-F238E27FC236}">
+              <a16:creationId xmlns:a16="http://schemas.microsoft.com/office/drawing/2014/main" id="{EE40AB45-ECFC-7929-641D-AC7B106940BB}"/>
+            </a:ext>
+          </a:extLst>
+        </p:cNvPr>
+        <p:cNvGrpSpPr/>
+        <p:nvPr/>
+      </p:nvGrpSpPr>
+      <p:grpSpPr>
+        <a:xfrm>
+          <a:off x="0" y="0"/>
+          <a:ext cx="0" cy="0"/>
+          <a:chOff x="0" y="0"/>
+          <a:chExt cx="0" cy="0"/>
+        </a:xfrm>
+      </p:grpSpPr>
+      <p:sp>
+        <p:nvSpPr>
+          <p:cNvPr id="2" name="Slide Image Placeholder 1">
+            <a:extLst>
+              <a:ext uri="{FF2B5EF4-FFF2-40B4-BE49-F238E27FC236}">
+                <a16:creationId xmlns:a16="http://schemas.microsoft.com/office/drawing/2014/main" id="{10B68FDB-3D4E-1F34-5B50-53EBDB67CE82}"/>
+              </a:ext>
+            </a:extLst>
+          </p:cNvPr>
+          <p:cNvSpPr>
+            <a:spLocks noGrp="1" noRot="1" noChangeAspect="1"/>
+          </p:cNvSpPr>
+          <p:nvPr>
+            <p:ph type="sldImg"/>
+          </p:nvPr>
+        </p:nvSpPr>
+        <p:spPr/>
+      </p:sp>
+      <p:sp>
+        <p:nvSpPr>
+          <p:cNvPr id="3" name="Notes Placeholder 2">
+            <a:extLst>
+              <a:ext uri="{FF2B5EF4-FFF2-40B4-BE49-F238E27FC236}">
+                <a16:creationId xmlns:a16="http://schemas.microsoft.com/office/drawing/2014/main" id="{50FBF334-9481-B967-6FDA-3E1D6772EF3D}"/>
+              </a:ext>
+            </a:extLst>
+          </p:cNvPr>
+          <p:cNvSpPr>
+            <a:spLocks noGrp="1"/>
+          </p:cNvSpPr>
+          <p:nvPr>
+            <p:ph type="body" idx="1"/>
+          </p:nvPr>
+        </p:nvSpPr>
+        <p:spPr/>
+        <p:txBody>
+          <a:bodyPr/>
+          <a:lstStyle/>
+          <a:p>
+            <a:endParaRPr lang="en-US" dirty="0"/>
+          </a:p>
+        </p:txBody>
+      </p:sp>
+      <p:sp>
+        <p:nvSpPr>
+          <p:cNvPr id="4" name="Slide Number Placeholder 3">
+            <a:extLst>
+              <a:ext uri="{FF2B5EF4-FFF2-40B4-BE49-F238E27FC236}">
+                <a16:creationId xmlns:a16="http://schemas.microsoft.com/office/drawing/2014/main" id="{A5856073-BB5F-27B4-E844-C4B566405FF2}"/>
+              </a:ext>
+            </a:extLst>
+          </p:cNvPr>
+          <p:cNvSpPr>
+            <a:spLocks noGrp="1"/>
+          </p:cNvSpPr>
+          <p:nvPr>
+            <p:ph type="sldNum" sz="quarter" idx="5"/>
+          </p:nvPr>
+        </p:nvSpPr>
+        <p:spPr/>
+        <p:txBody>
+          <a:bodyPr/>
+          <a:lstStyle/>
+          <a:p>
+            <a:fld id="{5068C1A6-6C9C-C342-8E0F-AE9AC9AFD13B}" type="slidenum">
+              <a:rPr lang="en-US" smtClean="0"/>
+              <a:t>14</a:t>
+            </a:fld>
+            <a:endParaRPr lang="en-US" dirty="0"/>
+          </a:p>
+        </p:txBody>
+      </p:sp>
+    </p:spTree>
+    <p:extLst>
+      <p:ext uri="{BB962C8B-B14F-4D97-AF65-F5344CB8AC3E}">
+        <p14:creationId xmlns:p14="http://schemas.microsoft.com/office/powerpoint/2010/main" val="3081826104"/>
+      </p:ext>
+    </p:extLst>
+  </p:cSld>
+  <p:clrMapOvr>
+    <a:masterClrMapping/>
+  </p:clrMapOvr>
+</p:notes>
+</file>
+
+<file path=ppt/notesSlides/notesSlide11.xml><?xml version="1.0" encoding="utf-8"?>
 <p:notes xmlns:a="http://schemas.openxmlformats.org/drawingml/2006/main" xmlns:r="http://schemas.openxmlformats.org/officeDocument/2006/relationships" xmlns:p="http://schemas.openxmlformats.org/presentationml/2006/main" showMasterSp="0" showMasterPhAnim="0">
   <p:cSld>
     <p:spTree>
@@ -1454,7 +1563,7 @@
 </p:notes>
 </file>
 
-<file path=ppt/notesSlides/notesSlide11.xml><?xml version="1.0" encoding="utf-8"?>
+<file path=ppt/notesSlides/notesSlide12.xml><?xml version="1.0" encoding="utf-8"?>
 <p:notes xmlns:a="http://schemas.openxmlformats.org/drawingml/2006/main" xmlns:r="http://schemas.openxmlformats.org/officeDocument/2006/relationships" xmlns:p="http://schemas.openxmlformats.org/presentationml/2006/main" showMasterSp="0" showMasterPhAnim="0">
   <p:cSld>
     <p:spTree>
@@ -1581,7 +1690,7 @@
 </p:notes>
 </file>
 
-<file path=ppt/notesSlides/notesSlide12.xml><?xml version="1.0" encoding="utf-8"?>
+<file path=ppt/notesSlides/notesSlide13.xml><?xml version="1.0" encoding="utf-8"?>
 <p:notes xmlns:a="http://schemas.openxmlformats.org/drawingml/2006/main" xmlns:r="http://schemas.openxmlformats.org/officeDocument/2006/relationships" xmlns:p="http://schemas.openxmlformats.org/presentationml/2006/main" showMasterSp="0" showMasterPhAnim="0">
   <p:cSld>
     <p:spTree>
@@ -1708,7 +1817,7 @@
 </p:notes>
 </file>
 
-<file path=ppt/notesSlides/notesSlide13.xml><?xml version="1.0" encoding="utf-8"?>
+<file path=ppt/notesSlides/notesSlide14.xml><?xml version="1.0" encoding="utf-8"?>
 <p:notes xmlns:a="http://schemas.openxmlformats.org/drawingml/2006/main" xmlns:r="http://schemas.openxmlformats.org/officeDocument/2006/relationships" xmlns:p="http://schemas.openxmlformats.org/presentationml/2006/main" showMasterSp="0" showMasterPhAnim="0">
   <p:cSld>
     <p:spTree>
@@ -1835,7 +1944,7 @@
 </p:notes>
 </file>
 
-<file path=ppt/notesSlides/notesSlide14.xml><?xml version="1.0" encoding="utf-8"?>
+<file path=ppt/notesSlides/notesSlide15.xml><?xml version="1.0" encoding="utf-8"?>
 <p:notes xmlns:a="http://schemas.openxmlformats.org/drawingml/2006/main" xmlns:r="http://schemas.openxmlformats.org/officeDocument/2006/relationships" xmlns:p="http://schemas.openxmlformats.org/presentationml/2006/main" showMasterSp="0" showMasterPhAnim="0">
   <p:cSld>
     <p:spTree>
@@ -1962,7 +2071,7 @@
 </p:notes>
 </file>
 
-<file path=ppt/notesSlides/notesSlide15.xml><?xml version="1.0" encoding="utf-8"?>
+<file path=ppt/notesSlides/notesSlide16.xml><?xml version="1.0" encoding="utf-8"?>
 <p:notes xmlns:a="http://schemas.openxmlformats.org/drawingml/2006/main" xmlns:r="http://schemas.openxmlformats.org/officeDocument/2006/relationships" xmlns:p="http://schemas.openxmlformats.org/presentationml/2006/main" showMasterSp="0" showMasterPhAnim="0">
   <p:cSld>
     <p:spTree>
@@ -2089,7 +2198,7 @@
 </p:notes>
 </file>
 
-<file path=ppt/notesSlides/notesSlide16.xml><?xml version="1.0" encoding="utf-8"?>
+<file path=ppt/notesSlides/notesSlide17.xml><?xml version="1.0" encoding="utf-8"?>
 <p:notes xmlns:a="http://schemas.openxmlformats.org/drawingml/2006/main" xmlns:r="http://schemas.openxmlformats.org/officeDocument/2006/relationships" xmlns:p="http://schemas.openxmlformats.org/presentationml/2006/main" showMasterSp="0" showMasterPhAnim="0">
   <p:cSld>
     <p:spTree>
@@ -2834,6 +2943,86 @@
               <a:t>spatial patterns are clear</a:t>
             </a:r>
           </a:p>
+          <a:p>
+            <a:endParaRPr lang="en-US" dirty="0"/>
+          </a:p>
+          <a:p>
+            <a:endParaRPr lang="en-US" dirty="0"/>
+          </a:p>
+          <a:p>
+            <a:endParaRPr lang="en-US" dirty="0"/>
+          </a:p>
+          <a:p>
+            <a:r>
+              <a:rPr lang="en-US" dirty="0"/>
+              <a:t>These two plots work together to explain both </a:t>
+            </a:r>
+            <a:r>
+              <a:rPr lang="en-US" b="1" dirty="0"/>
+              <a:t>what drives population change</a:t>
+            </a:r>
+            <a:r>
+              <a:rPr lang="en-US" dirty="0"/>
+              <a:t> and </a:t>
+            </a:r>
+            <a:r>
+              <a:rPr lang="en-US" b="1" dirty="0"/>
+              <a:t>when those drivers matter</a:t>
+            </a:r>
+            <a:r>
+              <a:rPr lang="en-US" dirty="0"/>
+              <a:t>.</a:t>
+            </a:r>
+          </a:p>
+          <a:p>
+            <a:r>
+              <a:rPr lang="en-US" dirty="0"/>
+              <a:t>On the right, the SHAP plot identifies the most important variables overall. We see that seismic activity, regional differences, and lagged population change are key drivers, which tells us that population dynamics are strongly influenced by structural conditions and persistence over time.</a:t>
+            </a:r>
+          </a:p>
+          <a:p>
+            <a:r>
+              <a:rPr lang="en-US" dirty="0"/>
+              <a:t>However, SHAP alone doesn’t tell us </a:t>
+            </a:r>
+            <a:r>
+              <a:rPr lang="en-US" i="1" dirty="0"/>
+              <a:t>when</a:t>
+            </a:r>
+            <a:r>
+              <a:rPr lang="en-US" dirty="0"/>
+              <a:t> these effects occur. That’s where the lead–lag analysis on the left comes in.</a:t>
+            </a:r>
+          </a:p>
+          <a:p>
+            <a:r>
+              <a:rPr lang="en-US" dirty="0"/>
+              <a:t>This plot shows that hurricane exposure is actually the most influential variable — but only at a one-year lag. In other words, the impact of hurricanes on population change is delayed, likely reflecting migration and recovery processes rather than immediate responses.</a:t>
+            </a:r>
+          </a:p>
+          <a:p>
+            <a:r>
+              <a:rPr lang="en-US" dirty="0"/>
+              <a:t>Seismic activity, by contrast, shows both immediate and short-term effects, while structural variables like vulnerability and income remain consistently important across time.</a:t>
+            </a:r>
+          </a:p>
+          <a:p>
+            <a:r>
+              <a:rPr lang="en-US" dirty="0"/>
+              <a:t>So together, these plots show that population change in Puerto Rico is not just driven by structural factors, but also by </a:t>
+            </a:r>
+            <a:r>
+              <a:rPr lang="en-US" b="1" dirty="0"/>
+              <a:t>delayed responses to shocks</a:t>
+            </a:r>
+            <a:r>
+              <a:rPr lang="en-US" dirty="0"/>
+              <a:t>, highlighting that timing plays a critical role in understanding demographic change.</a:t>
+            </a:r>
+          </a:p>
+          <a:p>
+            <a:endParaRPr lang="en-US" dirty="0"/>
+          </a:p>
         </p:txBody>
       </p:sp>
       <p:sp>
@@ -2877,7 +3066,13 @@
   <p:cSld>
     <p:spTree>
       <p:nvGrpSpPr>
-        <p:cNvPr id="1" name=""/>
+        <p:cNvPr id="1" name="">
+          <a:extLst>
+            <a:ext uri="{FF2B5EF4-FFF2-40B4-BE49-F238E27FC236}">
+              <a16:creationId xmlns:a16="http://schemas.microsoft.com/office/drawing/2014/main" id="{675258BF-2752-B391-56A9-F664D95346F8}"/>
+            </a:ext>
+          </a:extLst>
+        </p:cNvPr>
         <p:cNvGrpSpPr/>
         <p:nvPr/>
       </p:nvGrpSpPr>
@@ -2891,7 +3086,13 @@
       </p:grpSpPr>
       <p:sp>
         <p:nvSpPr>
-          <p:cNvPr id="2" name="Slide Image Placeholder 1"/>
+          <p:cNvPr id="2" name="Slide Image Placeholder 1">
+            <a:extLst>
+              <a:ext uri="{FF2B5EF4-FFF2-40B4-BE49-F238E27FC236}">
+                <a16:creationId xmlns:a16="http://schemas.microsoft.com/office/drawing/2014/main" id="{A075FE71-47E3-4CB3-EEB6-583D6D4DE9D2}"/>
+              </a:ext>
+            </a:extLst>
+          </p:cNvPr>
           <p:cNvSpPr>
             <a:spLocks noGrp="1" noRot="1" noChangeAspect="1"/>
           </p:cNvSpPr>
@@ -2903,7 +3104,13 @@
       </p:sp>
       <p:sp>
         <p:nvSpPr>
-          <p:cNvPr id="3" name="Notes Placeholder 2"/>
+          <p:cNvPr id="3" name="Notes Placeholder 2">
+            <a:extLst>
+              <a:ext uri="{FF2B5EF4-FFF2-40B4-BE49-F238E27FC236}">
+                <a16:creationId xmlns:a16="http://schemas.microsoft.com/office/drawing/2014/main" id="{CD33D1F1-E2B5-70B3-B317-B979A4B294B0}"/>
+              </a:ext>
+            </a:extLst>
+          </p:cNvPr>
           <p:cNvSpPr>
             <a:spLocks noGrp="1"/>
           </p:cNvSpPr>
@@ -2918,97 +3125,103 @@
           <a:p>
             <a:r>
               <a:rPr lang="en-US" dirty="0"/>
-              <a:t>In </a:t>
+              <a:t>This slide shows a lead–lag analysis, which helps us understand not just what matters, but when it matters.</a:t>
+            </a:r>
+          </a:p>
+          <a:p>
+            <a:r>
+              <a:rPr lang="en-US" dirty="0"/>
+              <a:t>The key result is that hurricane exposure has its strongest effect at a one-year lag, not immediately. This suggests that population responses—such as migration or displacement—occur after some delay.</a:t>
+            </a:r>
+          </a:p>
+          <a:p>
+            <a:r>
+              <a:rPr lang="en-US" dirty="0"/>
+              <a:t>Earthquake effects appear both immediate and slightly persistent, while structural factors like vulnerability remain important across multiple time periods.</a:t>
+            </a:r>
+          </a:p>
+          <a:p>
+            <a:r>
+              <a:rPr lang="en-US" dirty="0"/>
+              <a:t>Overall, this tells us that population change is not driven by instant shocks, but by delayed and evolving responses over time.</a:t>
+            </a:r>
+          </a:p>
+          <a:p>
+            <a:endParaRPr lang="en-US" dirty="0"/>
+          </a:p>
+          <a:p>
+            <a:endParaRPr lang="en-US" dirty="0"/>
+          </a:p>
+          <a:p>
+            <a:r>
+              <a:rPr lang="en-US" dirty="0"/>
+              <a:t>These two plots work together to explain both </a:t>
             </a:r>
             <a:r>
               <a:rPr lang="en-US" b="1" dirty="0"/>
-              <a:t>Phase 5</a:t>
-            </a:r>
-            <a:r>
-              <a:rPr lang="en-US" dirty="0"/>
-              <a:t>, I used clustering to group municipios based on:</a:t>
-            </a:r>
-          </a:p>
-          <a:p>
-            <a:r>
-              <a:rPr lang="en-US" dirty="0"/>
-              <a:t>Economic conditions (income, employment) </a:t>
-            </a:r>
-          </a:p>
-          <a:p>
-            <a:r>
-              <a:rPr lang="en-US" dirty="0"/>
-              <a:t>Vulnerability (SVI, poverty, housing) </a:t>
-            </a:r>
-          </a:p>
-          <a:p>
-            <a:r>
-              <a:rPr lang="en-US" dirty="0"/>
-              <a:t>Demographics (age structure, etc.) </a:t>
-            </a:r>
-          </a:p>
-          <a:p>
-            <a:br>
-              <a:rPr lang="en-US" dirty="0"/>
-            </a:br>
+              <a:t>what drives population change</a:t>
+            </a:r>
+            <a:r>
+              <a:rPr lang="en-US" dirty="0"/>
+              <a:t> and </a:t>
+            </a:r>
+            <a:r>
+              <a:rPr lang="en-US" b="1" dirty="0"/>
+              <a:t>when those drivers matter</a:t>
+            </a:r>
+            <a:r>
+              <a:rPr lang="en-US" dirty="0"/>
+              <a:t>.</a:t>
+            </a:r>
+          </a:p>
+          <a:p>
+            <a:r>
+              <a:rPr lang="en-US" dirty="0"/>
+              <a:t>On the right, the SHAP plot identifies the most important variables overall. We see that seismic activity, regional differences, and lagged population change are key drivers, which tells us that population dynamics are strongly influenced by structural conditions and persistence over time.</a:t>
+            </a:r>
+          </a:p>
+          <a:p>
+            <a:r>
+              <a:rPr lang="en-US" dirty="0"/>
+              <a:t>However, SHAP alone doesn’t tell us </a:t>
+            </a:r>
+            <a:r>
+              <a:rPr lang="en-US" i="1" dirty="0"/>
+              <a:t>when</a:t>
+            </a:r>
+            <a:r>
+              <a:rPr lang="en-US" dirty="0"/>
+              <a:t> these effects occur. That’s where the lead–lag analysis on the left comes in.</a:t>
+            </a:r>
+          </a:p>
+          <a:p>
+            <a:r>
+              <a:rPr lang="en-US" dirty="0"/>
+              <a:t>This plot shows that hurricane exposure is actually the most influential variable — but only at a one-year lag. In other words, the impact of hurricanes on population change is delayed, likely reflecting migration and recovery processes rather than immediate responses.</a:t>
+            </a:r>
+          </a:p>
+          <a:p>
+            <a:r>
+              <a:rPr lang="en-US" dirty="0"/>
+              <a:t>Seismic activity, by contrast, shows both immediate and short-term effects, while structural variables like vulnerability and income remain consistently important across time.</a:t>
+            </a:r>
+          </a:p>
+          <a:p>
+            <a:r>
+              <a:rPr lang="en-US" dirty="0"/>
+              <a:t>So together, these plots show that population change in Puerto Rico is not just driven by structural factors, but also by </a:t>
+            </a:r>
+            <a:r>
+              <a:rPr lang="en-US" b="1" dirty="0"/>
+              <a:t>delayed responses to shocks</a:t>
+            </a:r>
+            <a:r>
+              <a:rPr lang="en-US" dirty="0"/>
+              <a:t>, highlighting that timing plays a critical role in understanding demographic change.</a:t>
+            </a:r>
+          </a:p>
+          <a:p>
             <a:endParaRPr lang="en-US" dirty="0"/>
-          </a:p>
-          <a:p>
-            <a:r>
-              <a:rPr lang="en-US" b="1" dirty="0"/>
-              <a:t>Result:</a:t>
-            </a:r>
-          </a:p>
-          <a:p>
-            <a:r>
-              <a:rPr lang="en-US" dirty="0"/>
-              <a:t>I didn’t get random groups, but a </a:t>
-            </a:r>
-            <a:r>
-              <a:rPr lang="en-US" b="1" dirty="0"/>
-              <a:t>clear, repeatable patterns</a:t>
-            </a:r>
-          </a:p>
-          <a:p>
-            <a:endParaRPr lang="en-US" dirty="0"/>
-          </a:p>
-          <a:p>
-            <a:r>
-              <a:rPr lang="en-US" dirty="0"/>
-              <a:t>So instead of 78 completely unique municipios, I found:</a:t>
-            </a:r>
-          </a:p>
-          <a:p>
-            <a:r>
-              <a:rPr lang="en-US" dirty="0"/>
-              <a:t>A </a:t>
-            </a:r>
-            <a:r>
-              <a:rPr lang="en-US" b="1" dirty="0"/>
-              <a:t>small number of types</a:t>
-            </a:r>
-            <a:r>
-              <a:rPr lang="en-US" dirty="0"/>
-              <a:t>, like:</a:t>
-            </a:r>
-          </a:p>
-          <a:p>
-            <a:r>
-              <a:rPr lang="en-US" dirty="0"/>
-              <a:t>High vulnerability / declining areas </a:t>
-            </a:r>
-          </a:p>
-          <a:p>
-            <a:r>
-              <a:rPr lang="en-US" dirty="0"/>
-              <a:t>More stable / economically resilient areas </a:t>
-            </a:r>
-          </a:p>
-          <a:p>
-            <a:r>
-              <a:rPr lang="en-US" dirty="0"/>
-              <a:t>Intermediate or mixed regions</a:t>
-            </a:r>
           </a:p>
           <a:p>
             <a:endParaRPr lang="en-US" dirty="0"/>
@@ -3017,7 +3230,13 @@
       </p:sp>
       <p:sp>
         <p:nvSpPr>
-          <p:cNvPr id="4" name="Slide Number Placeholder 3"/>
+          <p:cNvPr id="4" name="Slide Number Placeholder 3">
+            <a:extLst>
+              <a:ext uri="{FF2B5EF4-FFF2-40B4-BE49-F238E27FC236}">
+                <a16:creationId xmlns:a16="http://schemas.microsoft.com/office/drawing/2014/main" id="{685C73E6-5BEC-A8F8-A1AF-781212921898}"/>
+              </a:ext>
+            </a:extLst>
+          </p:cNvPr>
           <p:cNvSpPr>
             <a:spLocks noGrp="1"/>
           </p:cNvSpPr>
@@ -3032,7 +3251,7 @@
           <a:p>
             <a:fld id="{5068C1A6-6C9C-C342-8E0F-AE9AC9AFD13B}" type="slidenum">
               <a:rPr lang="en-US" smtClean="0"/>
-              <a:t>8</a:t>
+              <a:t>6</a:t>
             </a:fld>
             <a:endParaRPr lang="en-US" dirty="0"/>
           </a:p>
@@ -3041,7 +3260,7 @@
     </p:spTree>
     <p:extLst>
       <p:ext uri="{BB962C8B-B14F-4D97-AF65-F5344CB8AC3E}">
-        <p14:creationId xmlns:p14="http://schemas.microsoft.com/office/powerpoint/2010/main" val="789598196"/>
+        <p14:creationId xmlns:p14="http://schemas.microsoft.com/office/powerpoint/2010/main" val="2308053651"/>
       </p:ext>
     </p:extLst>
   </p:cSld>
@@ -3096,204 +3315,97 @@
           <a:lstStyle/>
           <a:p>
             <a:r>
+              <a:rPr lang="en-US" dirty="0"/>
+              <a:t>In </a:t>
+            </a:r>
+            <a:r>
               <a:rPr lang="en-US" b="1" dirty="0"/>
-              <a:t>1. The "Anchor" (Historical vs. Forecast)</a:t>
-            </a:r>
+              <a:t>Phase 5</a:t>
+            </a:r>
+            <a:r>
+              <a:rPr lang="en-US" dirty="0"/>
+              <a:t>, I used clustering to group municipios based on:</a:t>
+            </a:r>
+          </a:p>
+          <a:p>
+            <a:r>
+              <a:rPr lang="en-US" dirty="0"/>
+              <a:t>Economic conditions (income, employment) </a:t>
+            </a:r>
+          </a:p>
+          <a:p>
+            <a:r>
+              <a:rPr lang="en-US" dirty="0"/>
+              <a:t>Vulnerability (SVI, poverty, housing) </a:t>
+            </a:r>
+          </a:p>
+          <a:p>
+            <a:r>
+              <a:rPr lang="en-US" dirty="0"/>
+              <a:t>Demographics (age structure, etc.) </a:t>
+            </a:r>
+          </a:p>
+          <a:p>
+            <a:br>
+              <a:rPr lang="en-US" dirty="0"/>
+            </a:br>
+            <a:endParaRPr lang="en-US" dirty="0"/>
           </a:p>
           <a:p>
             <a:r>
               <a:rPr lang="en-US" b="1" dirty="0"/>
-              <a:t>The Black Line (2014–2023):</a:t>
-            </a:r>
-            <a:r>
-              <a:rPr lang="en-US" dirty="0"/>
-              <a:t> This represents </a:t>
+              <a:t>Result:</a:t>
+            </a:r>
+          </a:p>
+          <a:p>
+            <a:r>
+              <a:rPr lang="en-US" dirty="0"/>
+              <a:t>I didn’t get random groups, but a </a:t>
             </a:r>
             <a:r>
               <a:rPr lang="en-US" b="1" dirty="0"/>
-              <a:t>Observed Data</a:t>
-            </a:r>
-            <a:r>
-              <a:rPr lang="en-US" dirty="0"/>
-              <a:t>. It establishes the baseline trend of population decline that the models are "learning" from.</a:t>
-            </a:r>
-          </a:p>
-          <a:p>
+              <a:t>clear, repeatable patterns</a:t>
+            </a:r>
+          </a:p>
+          <a:p>
+            <a:endParaRPr lang="en-US" dirty="0"/>
+          </a:p>
+          <a:p>
+            <a:r>
+              <a:rPr lang="en-US" dirty="0"/>
+              <a:t>So instead of 78 completely unique municipios, I found:</a:t>
+            </a:r>
+          </a:p>
+          <a:p>
+            <a:r>
+              <a:rPr lang="en-US" dirty="0"/>
+              <a:t>A </a:t>
+            </a:r>
             <a:r>
               <a:rPr lang="en-US" b="1" dirty="0"/>
-              <a:t>The Red Dashed Line (Current: 2023):</a:t>
-            </a:r>
-            <a:r>
-              <a:rPr lang="en-US" dirty="0"/>
-              <a:t> This is the </a:t>
-            </a:r>
-            <a:r>
-              <a:rPr lang="en-US" b="1" dirty="0"/>
-              <a:t>Pivot Point</a:t>
-            </a:r>
-            <a:r>
-              <a:rPr lang="en-US" dirty="0"/>
-              <a:t>. Everything to the left is fact; everything to the right is a probabilistic projection based on Phase 6 modeling.</a:t>
-            </a:r>
-          </a:p>
-          <a:p>
-            <a:endParaRPr lang="en-US" dirty="0"/>
-          </a:p>
-          <a:p>
-            <a:r>
-              <a:rPr lang="en-US" b="1" dirty="0"/>
-              <a:t>2. The "Median" (The Expected Path)</a:t>
-            </a:r>
-          </a:p>
-          <a:p>
-            <a:r>
-              <a:rPr lang="en-US" dirty="0"/>
-              <a:t>The center line represents the </a:t>
-            </a:r>
-            <a:r>
-              <a:rPr lang="en-US" b="1" dirty="0"/>
-              <a:t>P50 (Median) Forecast</a:t>
-            </a:r>
-            <a:r>
-              <a:rPr lang="en-US" dirty="0"/>
-              <a:t>.</a:t>
-            </a:r>
-          </a:p>
-          <a:p>
-            <a:r>
-              <a:rPr lang="en-US" b="1" dirty="0"/>
-              <a:t>The Insight:</a:t>
-            </a:r>
-            <a:r>
-              <a:rPr lang="en-US" dirty="0"/>
-              <a:t> Our analysis suggests that the most likely outcome is a continued, linear decline, bringing the population toward the </a:t>
-            </a:r>
-            <a:r>
-              <a:rPr lang="en-US" b="1" dirty="0"/>
-              <a:t>3.0M mark by 2030</a:t>
-            </a:r>
-            <a:r>
-              <a:rPr lang="en-US" dirty="0"/>
-              <a:t>.</a:t>
-            </a:r>
-          </a:p>
-          <a:p>
-            <a:endParaRPr lang="en-US" dirty="0"/>
-          </a:p>
-          <a:p>
-            <a:r>
-              <a:rPr lang="en-US" b="1" dirty="0"/>
-              <a:t>3. Understanding the "Fan" (The Probability Bands)</a:t>
-            </a:r>
-          </a:p>
-          <a:p>
-            <a:r>
-              <a:rPr lang="en-US" dirty="0"/>
-              <a:t>Instead of giving a single "guess," the fan shows a range of possible futures:</a:t>
-            </a:r>
-          </a:p>
-          <a:p>
-            <a:r>
-              <a:rPr lang="en-US" b="1" dirty="0"/>
-              <a:t>The Core (Central Bands):</a:t>
-            </a:r>
-            <a:r>
-              <a:rPr lang="en-US" dirty="0"/>
-              <a:t> The green and teal areas represent the </a:t>
-            </a:r>
-            <a:r>
-              <a:rPr lang="en-US" b="1" dirty="0"/>
-              <a:t>50% probability interval</a:t>
-            </a:r>
-            <a:r>
-              <a:rPr lang="en-US" dirty="0"/>
-              <a:t>. If current structural conditions remain stable, the population will almost certainly land within this range.</a:t>
-            </a:r>
-          </a:p>
-          <a:p>
-            <a:r>
-              <a:rPr lang="en-US" b="1" dirty="0"/>
-              <a:t>The Tails (Outer Bands):</a:t>
-            </a:r>
-            <a:r>
-              <a:rPr lang="en-US" dirty="0"/>
-              <a:t> The dark purple and light orange areas represent </a:t>
-            </a:r>
-            <a:r>
-              <a:rPr lang="en-US" b="1" dirty="0"/>
-              <a:t>extreme scenarios</a:t>
-            </a:r>
-            <a:r>
-              <a:rPr lang="en-US" dirty="0"/>
-              <a:t> (Tail Risks).</a:t>
-            </a:r>
-          </a:p>
-          <a:p>
-            <a:pPr lvl="1"/>
-            <a:r>
-              <a:rPr lang="en-US" b="1" dirty="0"/>
-              <a:t>Upper Tail (Orange):</a:t>
-            </a:r>
-            <a:r>
-              <a:rPr lang="en-US" dirty="0"/>
-              <a:t> Represents a "Favorable" scenario where decline slows significantly (e.g., due to economic stabilization or migration shifts).</a:t>
-            </a:r>
-          </a:p>
-          <a:p>
-            <a:pPr lvl="1"/>
-            <a:r>
-              <a:rPr lang="en-US" b="1" dirty="0"/>
-              <a:t>Lower Tail (Dark Purple):</a:t>
-            </a:r>
-            <a:r>
-              <a:rPr lang="en-US" dirty="0"/>
-              <a:t> Represents an "Adverse" scenario where decline accelerates (e.g., due to external shocks or deepening structural vulnerability).</a:t>
-            </a:r>
-          </a:p>
-          <a:p>
-            <a:pPr lvl="1"/>
-            <a:endParaRPr lang="en-US" dirty="0"/>
-          </a:p>
-          <a:p>
-            <a:r>
-              <a:rPr lang="en-US" b="1" dirty="0"/>
-              <a:t>4. Key Takeaway for Policy</a:t>
-            </a:r>
-          </a:p>
-          <a:p>
-            <a:r>
-              <a:rPr lang="en-US" b="1" dirty="0"/>
-              <a:t>Systemic Persistence:</a:t>
-            </a:r>
-            <a:r>
-              <a:rPr lang="en-US" dirty="0"/>
-              <a:t> Even in the most "optimistic" scenario (the top of the fan), the island does not return to growth by 2030.</a:t>
-            </a:r>
-          </a:p>
-          <a:p>
-            <a:r>
-              <a:rPr lang="en-US" b="1" dirty="0"/>
-              <a:t>Widening Uncertainty:</a:t>
-            </a:r>
-            <a:r>
-              <a:rPr lang="en-US" dirty="0"/>
-              <a:t> The "width" of the fan at 2030 illustrates that while we are certain about the </a:t>
-            </a:r>
-            <a:r>
-              <a:rPr lang="en-US" i="1" dirty="0"/>
-              <a:t>direction</a:t>
-            </a:r>
-            <a:r>
-              <a:rPr lang="en-US" dirty="0"/>
-              <a:t> of the trend, the </a:t>
-            </a:r>
-            <a:r>
-              <a:rPr lang="en-US" i="1" dirty="0"/>
-              <a:t>magnitude</a:t>
-            </a:r>
-            <a:r>
-              <a:rPr lang="en-US" dirty="0"/>
-              <a:t> of the loss is subject to high volatility, requiring flexible regional planning.</a:t>
+              <a:t>small number of types</a:t>
+            </a:r>
+            <a:r>
+              <a:rPr lang="en-US" dirty="0"/>
+              <a:t>, like:</a:t>
+            </a:r>
+          </a:p>
+          <a:p>
+            <a:r>
+              <a:rPr lang="en-US" dirty="0"/>
+              <a:t>High vulnerability / declining areas </a:t>
+            </a:r>
+          </a:p>
+          <a:p>
+            <a:r>
+              <a:rPr lang="en-US" dirty="0"/>
+              <a:t>More stable / economically resilient areas </a:t>
+            </a:r>
+          </a:p>
+          <a:p>
+            <a:r>
+              <a:rPr lang="en-US" dirty="0"/>
+              <a:t>Intermediate or mixed regions</a:t>
             </a:r>
           </a:p>
           <a:p>
@@ -3327,6 +3439,292 @@
     </p:spTree>
     <p:extLst>
       <p:ext uri="{BB962C8B-B14F-4D97-AF65-F5344CB8AC3E}">
+        <p14:creationId xmlns:p14="http://schemas.microsoft.com/office/powerpoint/2010/main" val="789598196"/>
+      </p:ext>
+    </p:extLst>
+  </p:cSld>
+  <p:clrMapOvr>
+    <a:masterClrMapping/>
+  </p:clrMapOvr>
+</p:notes>
+</file>
+
+<file path=ppt/notesSlides/notesSlide8.xml><?xml version="1.0" encoding="utf-8"?>
+<p:notes xmlns:a="http://schemas.openxmlformats.org/drawingml/2006/main" xmlns:r="http://schemas.openxmlformats.org/officeDocument/2006/relationships" xmlns:p="http://schemas.openxmlformats.org/presentationml/2006/main">
+  <p:cSld>
+    <p:spTree>
+      <p:nvGrpSpPr>
+        <p:cNvPr id="1" name=""/>
+        <p:cNvGrpSpPr/>
+        <p:nvPr/>
+      </p:nvGrpSpPr>
+      <p:grpSpPr>
+        <a:xfrm>
+          <a:off x="0" y="0"/>
+          <a:ext cx="0" cy="0"/>
+          <a:chOff x="0" y="0"/>
+          <a:chExt cx="0" cy="0"/>
+        </a:xfrm>
+      </p:grpSpPr>
+      <p:sp>
+        <p:nvSpPr>
+          <p:cNvPr id="2" name="Slide Image Placeholder 1"/>
+          <p:cNvSpPr>
+            <a:spLocks noGrp="1" noRot="1" noChangeAspect="1"/>
+          </p:cNvSpPr>
+          <p:nvPr>
+            <p:ph type="sldImg"/>
+          </p:nvPr>
+        </p:nvSpPr>
+        <p:spPr/>
+      </p:sp>
+      <p:sp>
+        <p:nvSpPr>
+          <p:cNvPr id="3" name="Notes Placeholder 2"/>
+          <p:cNvSpPr>
+            <a:spLocks noGrp="1"/>
+          </p:cNvSpPr>
+          <p:nvPr>
+            <p:ph type="body" idx="1"/>
+          </p:nvPr>
+        </p:nvSpPr>
+        <p:spPr/>
+        <p:txBody>
+          <a:bodyPr/>
+          <a:lstStyle/>
+          <a:p>
+            <a:r>
+              <a:rPr lang="en-US" b="1" dirty="0"/>
+              <a:t>1. The "Anchor" (Historical vs. Forecast)</a:t>
+            </a:r>
+          </a:p>
+          <a:p>
+            <a:r>
+              <a:rPr lang="en-US" b="1" dirty="0"/>
+              <a:t>The Black Line (2014–2023):</a:t>
+            </a:r>
+            <a:r>
+              <a:rPr lang="en-US" dirty="0"/>
+              <a:t> This represents </a:t>
+            </a:r>
+            <a:r>
+              <a:rPr lang="en-US" b="1" dirty="0"/>
+              <a:t>Observed Data</a:t>
+            </a:r>
+            <a:r>
+              <a:rPr lang="en-US" dirty="0"/>
+              <a:t>. It establishes the baseline trend of population decline that the models are "learning" from.</a:t>
+            </a:r>
+          </a:p>
+          <a:p>
+            <a:r>
+              <a:rPr lang="en-US" b="1" dirty="0"/>
+              <a:t>The Red Dashed Line (Current: 2023):</a:t>
+            </a:r>
+            <a:r>
+              <a:rPr lang="en-US" dirty="0"/>
+              <a:t> This is the </a:t>
+            </a:r>
+            <a:r>
+              <a:rPr lang="en-US" b="1" dirty="0"/>
+              <a:t>Pivot Point</a:t>
+            </a:r>
+            <a:r>
+              <a:rPr lang="en-US" dirty="0"/>
+              <a:t>. Everything to the left is fact; everything to the right is a probabilistic projection based on Phase 6 modeling.</a:t>
+            </a:r>
+          </a:p>
+          <a:p>
+            <a:endParaRPr lang="en-US" dirty="0"/>
+          </a:p>
+          <a:p>
+            <a:r>
+              <a:rPr lang="en-US" b="1" dirty="0"/>
+              <a:t>2. The "Median" (The Expected Path)</a:t>
+            </a:r>
+          </a:p>
+          <a:p>
+            <a:r>
+              <a:rPr lang="en-US" dirty="0"/>
+              <a:t>The center line represents the </a:t>
+            </a:r>
+            <a:r>
+              <a:rPr lang="en-US" b="1" dirty="0"/>
+              <a:t>P50 (Median) Forecast</a:t>
+            </a:r>
+            <a:r>
+              <a:rPr lang="en-US" dirty="0"/>
+              <a:t>.</a:t>
+            </a:r>
+          </a:p>
+          <a:p>
+            <a:r>
+              <a:rPr lang="en-US" b="1" dirty="0"/>
+              <a:t>The Insight:</a:t>
+            </a:r>
+            <a:r>
+              <a:rPr lang="en-US" dirty="0"/>
+              <a:t> Our analysis suggests that the most likely outcome is a continued, linear decline, bringing the population toward the </a:t>
+            </a:r>
+            <a:r>
+              <a:rPr lang="en-US" b="1" dirty="0"/>
+              <a:t>3.0M mark by 2030</a:t>
+            </a:r>
+            <a:r>
+              <a:rPr lang="en-US" dirty="0"/>
+              <a:t>.</a:t>
+            </a:r>
+          </a:p>
+          <a:p>
+            <a:endParaRPr lang="en-US" dirty="0"/>
+          </a:p>
+          <a:p>
+            <a:r>
+              <a:rPr lang="en-US" b="1" dirty="0"/>
+              <a:t>3. Understanding the "Fan" (The Probability Bands)</a:t>
+            </a:r>
+          </a:p>
+          <a:p>
+            <a:r>
+              <a:rPr lang="en-US" dirty="0"/>
+              <a:t>Instead of giving a single "guess," the fan shows a range of possible futures:</a:t>
+            </a:r>
+          </a:p>
+          <a:p>
+            <a:r>
+              <a:rPr lang="en-US" b="1" dirty="0"/>
+              <a:t>The Core (Central Bands):</a:t>
+            </a:r>
+            <a:r>
+              <a:rPr lang="en-US" dirty="0"/>
+              <a:t> The green and teal areas represent the </a:t>
+            </a:r>
+            <a:r>
+              <a:rPr lang="en-US" b="1" dirty="0"/>
+              <a:t>50% probability interval</a:t>
+            </a:r>
+            <a:r>
+              <a:rPr lang="en-US" dirty="0"/>
+              <a:t>. If current structural conditions remain stable, the population will almost certainly land within this range.</a:t>
+            </a:r>
+          </a:p>
+          <a:p>
+            <a:r>
+              <a:rPr lang="en-US" b="1" dirty="0"/>
+              <a:t>The Tails (Outer Bands):</a:t>
+            </a:r>
+            <a:r>
+              <a:rPr lang="en-US" dirty="0"/>
+              <a:t> The dark purple and light orange areas represent </a:t>
+            </a:r>
+            <a:r>
+              <a:rPr lang="en-US" b="1" dirty="0"/>
+              <a:t>extreme scenarios</a:t>
+            </a:r>
+            <a:r>
+              <a:rPr lang="en-US" dirty="0"/>
+              <a:t> (Tail Risks).</a:t>
+            </a:r>
+          </a:p>
+          <a:p>
+            <a:pPr lvl="1"/>
+            <a:r>
+              <a:rPr lang="en-US" b="1" dirty="0"/>
+              <a:t>Upper Tail (Orange):</a:t>
+            </a:r>
+            <a:r>
+              <a:rPr lang="en-US" dirty="0"/>
+              <a:t> Represents a "Favorable" scenario where decline slows significantly (e.g., due to economic stabilization or migration shifts).</a:t>
+            </a:r>
+          </a:p>
+          <a:p>
+            <a:pPr lvl="1"/>
+            <a:r>
+              <a:rPr lang="en-US" b="1" dirty="0"/>
+              <a:t>Lower Tail (Dark Purple):</a:t>
+            </a:r>
+            <a:r>
+              <a:rPr lang="en-US" dirty="0"/>
+              <a:t> Represents an "Adverse" scenario where decline accelerates (e.g., due to external shocks or deepening structural vulnerability).</a:t>
+            </a:r>
+          </a:p>
+          <a:p>
+            <a:pPr lvl="1"/>
+            <a:endParaRPr lang="en-US" dirty="0"/>
+          </a:p>
+          <a:p>
+            <a:r>
+              <a:rPr lang="en-US" b="1" dirty="0"/>
+              <a:t>4. Key Takeaway for Policy</a:t>
+            </a:r>
+          </a:p>
+          <a:p>
+            <a:r>
+              <a:rPr lang="en-US" b="1" dirty="0"/>
+              <a:t>Systemic Persistence:</a:t>
+            </a:r>
+            <a:r>
+              <a:rPr lang="en-US" dirty="0"/>
+              <a:t> Even in the most "optimistic" scenario (the top of the fan), the island does not return to growth by 2030.</a:t>
+            </a:r>
+          </a:p>
+          <a:p>
+            <a:r>
+              <a:rPr lang="en-US" b="1" dirty="0"/>
+              <a:t>Widening Uncertainty:</a:t>
+            </a:r>
+            <a:r>
+              <a:rPr lang="en-US" dirty="0"/>
+              <a:t> The "width" of the fan at 2030 illustrates that while we are certain about the </a:t>
+            </a:r>
+            <a:r>
+              <a:rPr lang="en-US" i="1" dirty="0"/>
+              <a:t>direction</a:t>
+            </a:r>
+            <a:r>
+              <a:rPr lang="en-US" dirty="0"/>
+              <a:t> of the trend, the </a:t>
+            </a:r>
+            <a:r>
+              <a:rPr lang="en-US" i="1" dirty="0"/>
+              <a:t>magnitude</a:t>
+            </a:r>
+            <a:r>
+              <a:rPr lang="en-US" dirty="0"/>
+              <a:t> of the loss is subject to high volatility, requiring flexible regional planning.</a:t>
+            </a:r>
+          </a:p>
+          <a:p>
+            <a:endParaRPr lang="en-US" dirty="0"/>
+          </a:p>
+        </p:txBody>
+      </p:sp>
+      <p:sp>
+        <p:nvSpPr>
+          <p:cNvPr id="4" name="Slide Number Placeholder 3"/>
+          <p:cNvSpPr>
+            <a:spLocks noGrp="1"/>
+          </p:cNvSpPr>
+          <p:nvPr>
+            <p:ph type="sldNum" sz="quarter" idx="5"/>
+          </p:nvPr>
+        </p:nvSpPr>
+        <p:spPr/>
+        <p:txBody>
+          <a:bodyPr/>
+          <a:lstStyle/>
+          <a:p>
+            <a:fld id="{5068C1A6-6C9C-C342-8E0F-AE9AC9AFD13B}" type="slidenum">
+              <a:rPr lang="en-US" smtClean="0"/>
+              <a:t>10</a:t>
+            </a:fld>
+            <a:endParaRPr lang="en-US" dirty="0"/>
+          </a:p>
+        </p:txBody>
+      </p:sp>
+    </p:spTree>
+    <p:extLst>
+      <p:ext uri="{BB962C8B-B14F-4D97-AF65-F5344CB8AC3E}">
         <p14:creationId xmlns:p14="http://schemas.microsoft.com/office/powerpoint/2010/main" val="2989634620"/>
       </p:ext>
     </p:extLst>
@@ -3337,7 +3735,7 @@
 </p:notes>
 </file>
 
-<file path=ppt/notesSlides/notesSlide8.xml><?xml version="1.0" encoding="utf-8"?>
+<file path=ppt/notesSlides/notesSlide9.xml><?xml version="1.0" encoding="utf-8"?>
 <p:notes xmlns:a="http://schemas.openxmlformats.org/drawingml/2006/main" xmlns:r="http://schemas.openxmlformats.org/officeDocument/2006/relationships" xmlns:p="http://schemas.openxmlformats.org/presentationml/2006/main">
   <p:cSld>
     <p:spTree>
@@ -3628,7 +4026,7 @@
           <a:p>
             <a:fld id="{5068C1A6-6C9C-C342-8E0F-AE9AC9AFD13B}" type="slidenum">
               <a:rPr lang="en-US" smtClean="0"/>
-              <a:t>10</a:t>
+              <a:t>11</a:t>
             </a:fld>
             <a:endParaRPr lang="en-US" dirty="0"/>
           </a:p>
@@ -3638,114 +4036,6 @@
     <p:extLst>
       <p:ext uri="{BB962C8B-B14F-4D97-AF65-F5344CB8AC3E}">
         <p14:creationId xmlns:p14="http://schemas.microsoft.com/office/powerpoint/2010/main" val="1746274542"/>
-      </p:ext>
-    </p:extLst>
-  </p:cSld>
-  <p:clrMapOvr>
-    <a:masterClrMapping/>
-  </p:clrMapOvr>
-</p:notes>
-</file>
-
-<file path=ppt/notesSlides/notesSlide9.xml><?xml version="1.0" encoding="utf-8"?>
-<p:notes xmlns:a="http://schemas.openxmlformats.org/drawingml/2006/main" xmlns:r="http://schemas.openxmlformats.org/officeDocument/2006/relationships" xmlns:p="http://schemas.openxmlformats.org/presentationml/2006/main">
-  <p:cSld>
-    <p:spTree>
-      <p:nvGrpSpPr>
-        <p:cNvPr id="1" name="">
-          <a:extLst>
-            <a:ext uri="{FF2B5EF4-FFF2-40B4-BE49-F238E27FC236}">
-              <a16:creationId xmlns:a16="http://schemas.microsoft.com/office/drawing/2014/main" id="{EE40AB45-ECFC-7929-641D-AC7B106940BB}"/>
-            </a:ext>
-          </a:extLst>
-        </p:cNvPr>
-        <p:cNvGrpSpPr/>
-        <p:nvPr/>
-      </p:nvGrpSpPr>
-      <p:grpSpPr>
-        <a:xfrm>
-          <a:off x="0" y="0"/>
-          <a:ext cx="0" cy="0"/>
-          <a:chOff x="0" y="0"/>
-          <a:chExt cx="0" cy="0"/>
-        </a:xfrm>
-      </p:grpSpPr>
-      <p:sp>
-        <p:nvSpPr>
-          <p:cNvPr id="2" name="Slide Image Placeholder 1">
-            <a:extLst>
-              <a:ext uri="{FF2B5EF4-FFF2-40B4-BE49-F238E27FC236}">
-                <a16:creationId xmlns:a16="http://schemas.microsoft.com/office/drawing/2014/main" id="{10B68FDB-3D4E-1F34-5B50-53EBDB67CE82}"/>
-              </a:ext>
-            </a:extLst>
-          </p:cNvPr>
-          <p:cNvSpPr>
-            <a:spLocks noGrp="1" noRot="1" noChangeAspect="1"/>
-          </p:cNvSpPr>
-          <p:nvPr>
-            <p:ph type="sldImg"/>
-          </p:nvPr>
-        </p:nvSpPr>
-        <p:spPr/>
-      </p:sp>
-      <p:sp>
-        <p:nvSpPr>
-          <p:cNvPr id="3" name="Notes Placeholder 2">
-            <a:extLst>
-              <a:ext uri="{FF2B5EF4-FFF2-40B4-BE49-F238E27FC236}">
-                <a16:creationId xmlns:a16="http://schemas.microsoft.com/office/drawing/2014/main" id="{50FBF334-9481-B967-6FDA-3E1D6772EF3D}"/>
-              </a:ext>
-            </a:extLst>
-          </p:cNvPr>
-          <p:cNvSpPr>
-            <a:spLocks noGrp="1"/>
-          </p:cNvSpPr>
-          <p:nvPr>
-            <p:ph type="body" idx="1"/>
-          </p:nvPr>
-        </p:nvSpPr>
-        <p:spPr/>
-        <p:txBody>
-          <a:bodyPr/>
-          <a:lstStyle/>
-          <a:p>
-            <a:endParaRPr lang="en-US" dirty="0"/>
-          </a:p>
-        </p:txBody>
-      </p:sp>
-      <p:sp>
-        <p:nvSpPr>
-          <p:cNvPr id="4" name="Slide Number Placeholder 3">
-            <a:extLst>
-              <a:ext uri="{FF2B5EF4-FFF2-40B4-BE49-F238E27FC236}">
-                <a16:creationId xmlns:a16="http://schemas.microsoft.com/office/drawing/2014/main" id="{A5856073-BB5F-27B4-E844-C4B566405FF2}"/>
-              </a:ext>
-            </a:extLst>
-          </p:cNvPr>
-          <p:cNvSpPr>
-            <a:spLocks noGrp="1"/>
-          </p:cNvSpPr>
-          <p:nvPr>
-            <p:ph type="sldNum" sz="quarter" idx="5"/>
-          </p:nvPr>
-        </p:nvSpPr>
-        <p:spPr/>
-        <p:txBody>
-          <a:bodyPr/>
-          <a:lstStyle/>
-          <a:p>
-            <a:fld id="{5068C1A6-6C9C-C342-8E0F-AE9AC9AFD13B}" type="slidenum">
-              <a:rPr lang="en-US" smtClean="0"/>
-              <a:t>13</a:t>
-            </a:fld>
-            <a:endParaRPr lang="en-US" dirty="0"/>
-          </a:p>
-        </p:txBody>
-      </p:sp>
-    </p:spTree>
-    <p:extLst>
-      <p:ext uri="{BB962C8B-B14F-4D97-AF65-F5344CB8AC3E}">
-        <p14:creationId xmlns:p14="http://schemas.microsoft.com/office/powerpoint/2010/main" val="3081826104"/>
       </p:ext>
     </p:extLst>
   </p:cSld>
@@ -7925,6 +8215,310 @@
         <p:cNvPr id="1" name="">
           <a:extLst>
             <a:ext uri="{FF2B5EF4-FFF2-40B4-BE49-F238E27FC236}">
+              <a16:creationId xmlns:a16="http://schemas.microsoft.com/office/drawing/2014/main" id="{7E0CB461-06C7-B3FE-2FD3-A6EAA2C2C6C6}"/>
+            </a:ext>
+          </a:extLst>
+        </p:cNvPr>
+        <p:cNvGrpSpPr/>
+        <p:nvPr/>
+      </p:nvGrpSpPr>
+      <p:grpSpPr>
+        <a:xfrm>
+          <a:off x="0" y="0"/>
+          <a:ext cx="0" cy="0"/>
+          <a:chOff x="0" y="0"/>
+          <a:chExt cx="0" cy="0"/>
+        </a:xfrm>
+      </p:grpSpPr>
+      <p:sp>
+        <p:nvSpPr>
+          <p:cNvPr id="4" name="Rectangle 3">
+            <a:extLst>
+              <a:ext uri="{FF2B5EF4-FFF2-40B4-BE49-F238E27FC236}">
+                <a16:creationId xmlns:a16="http://schemas.microsoft.com/office/drawing/2014/main" id="{46AFF467-EA34-A1E1-7D27-49257098751A}"/>
+              </a:ext>
+            </a:extLst>
+          </p:cNvPr>
+          <p:cNvSpPr/>
+          <p:nvPr/>
+        </p:nvSpPr>
+        <p:spPr>
+          <a:xfrm>
+            <a:off x="0" y="196343"/>
+            <a:ext cx="7199290" cy="1007423"/>
+          </a:xfrm>
+          <a:prstGeom prst="rect">
+            <a:avLst/>
+          </a:prstGeom>
+          <a:solidFill>
+            <a:srgbClr val="CC0033"/>
+          </a:solidFill>
+          <a:ln>
+            <a:noFill/>
+          </a:ln>
+        </p:spPr>
+        <p:style>
+          <a:lnRef idx="1">
+            <a:schemeClr val="accent1"/>
+          </a:lnRef>
+          <a:fillRef idx="3">
+            <a:schemeClr val="accent1"/>
+          </a:fillRef>
+          <a:effectRef idx="2">
+            <a:schemeClr val="accent1"/>
+          </a:effectRef>
+          <a:fontRef idx="minor">
+            <a:schemeClr val="lt1"/>
+          </a:fontRef>
+        </p:style>
+        <p:txBody>
+          <a:bodyPr rtlCol="0" anchor="ctr"/>
+          <a:lstStyle/>
+          <a:p>
+            <a:pPr algn="ctr"/>
+            <a:endParaRPr lang="en-US" dirty="0">
+              <a:solidFill>
+                <a:schemeClr val="accent1"/>
+              </a:solidFill>
+            </a:endParaRPr>
+          </a:p>
+        </p:txBody>
+      </p:sp>
+      <p:sp>
+        <p:nvSpPr>
+          <p:cNvPr id="5" name="Title 10">
+            <a:extLst>
+              <a:ext uri="{FF2B5EF4-FFF2-40B4-BE49-F238E27FC236}">
+                <a16:creationId xmlns:a16="http://schemas.microsoft.com/office/drawing/2014/main" id="{1C9245BE-7F46-5541-F240-56BA0A3CBFE3}"/>
+              </a:ext>
+            </a:extLst>
+          </p:cNvPr>
+          <p:cNvSpPr txBox="1">
+            <a:spLocks/>
+          </p:cNvSpPr>
+          <p:nvPr/>
+        </p:nvSpPr>
+        <p:spPr>
+          <a:xfrm>
+            <a:off x="459357" y="361539"/>
+            <a:ext cx="6546750" cy="719563"/>
+          </a:xfrm>
+          <a:prstGeom prst="rect">
+            <a:avLst/>
+          </a:prstGeom>
+        </p:spPr>
+        <p:txBody>
+          <a:bodyPr anchor="ctr" anchorCtr="0">
+            <a:noAutofit/>
+          </a:bodyPr>
+          <a:lstStyle>
+            <a:lvl1pPr algn="ctr" defTabSz="457200" rtl="0" eaLnBrk="1" latinLnBrk="0" hangingPunct="1">
+              <a:spcBef>
+                <a:spcPct val="0"/>
+              </a:spcBef>
+              <a:buNone/>
+              <a:defRPr sz="4400" kern="1200">
+                <a:solidFill>
+                  <a:schemeClr val="tx1"/>
+                </a:solidFill>
+                <a:latin typeface="+mj-lt"/>
+                <a:ea typeface="+mj-ea"/>
+                <a:cs typeface="+mj-cs"/>
+              </a:defRPr>
+            </a:lvl1pPr>
+          </a:lstStyle>
+          <a:p>
+            <a:pPr lvl="0"/>
+            <a:r>
+              <a:rPr lang="en-US" sz="3200" b="1" dirty="0">
+                <a:solidFill>
+                  <a:schemeClr val="bg1"/>
+                </a:solidFill>
+              </a:rPr>
+              <a:t>Structural Patterns </a:t>
+            </a:r>
+          </a:p>
+          <a:p>
+            <a:pPr lvl="0"/>
+            <a:r>
+              <a:rPr lang="en-US" sz="3200" b="1" dirty="0">
+                <a:solidFill>
+                  <a:schemeClr val="bg1"/>
+                </a:solidFill>
+              </a:rPr>
+              <a:t>(Beyond Prediction)</a:t>
+            </a:r>
+          </a:p>
+        </p:txBody>
+      </p:sp>
+      <p:sp>
+        <p:nvSpPr>
+          <p:cNvPr id="11" name="TextBox 10">
+            <a:extLst>
+              <a:ext uri="{FF2B5EF4-FFF2-40B4-BE49-F238E27FC236}">
+                <a16:creationId xmlns:a16="http://schemas.microsoft.com/office/drawing/2014/main" id="{5F60B027-7280-1B08-F112-1AB1AFF3FADD}"/>
+              </a:ext>
+            </a:extLst>
+          </p:cNvPr>
+          <p:cNvSpPr txBox="1"/>
+          <p:nvPr/>
+        </p:nvSpPr>
+        <p:spPr>
+          <a:xfrm>
+            <a:off x="139613" y="1368962"/>
+            <a:ext cx="9560053" cy="4708981"/>
+          </a:xfrm>
+          <a:prstGeom prst="rect">
+            <a:avLst/>
+          </a:prstGeom>
+          <a:noFill/>
+        </p:spPr>
+        <p:txBody>
+          <a:bodyPr wrap="square">
+            <a:spAutoFit/>
+          </a:bodyPr>
+          <a:lstStyle/>
+          <a:p>
+            <a:r>
+              <a:rPr lang="en-US" sz="2000" b="1" dirty="0"/>
+              <a:t>What emerges</a:t>
+            </a:r>
+          </a:p>
+          <a:p>
+            <a:pPr marL="285750" indent="-285750">
+              <a:buFont typeface="Arial" panose="020B0604020202020204" pitchFamily="34" charset="0"/>
+              <a:buChar char="•"/>
+            </a:pPr>
+            <a:r>
+              <a:rPr lang="en-US" sz="2000" dirty="0"/>
+              <a:t>Distinct municipal typologies</a:t>
+            </a:r>
+          </a:p>
+          <a:p>
+            <a:pPr marL="285750" indent="-285750">
+              <a:buFont typeface="Arial" panose="020B0604020202020204" pitchFamily="34" charset="0"/>
+              <a:buChar char="•"/>
+            </a:pPr>
+            <a:r>
+              <a:rPr lang="en-US" sz="2000" dirty="0"/>
+              <a:t>Clear regional clustering</a:t>
+            </a:r>
+            <a:br>
+              <a:rPr lang="en-US" sz="2000" dirty="0"/>
+            </a:br>
+            <a:endParaRPr lang="en-US" sz="2000" dirty="0"/>
+          </a:p>
+          <a:p>
+            <a:r>
+              <a:rPr lang="en-US" sz="2000" b="1" dirty="0"/>
+              <a:t>Key result</a:t>
+            </a:r>
+          </a:p>
+          <a:p>
+            <a:pPr marL="285750" indent="-285750">
+              <a:buFont typeface="Arial" panose="020B0604020202020204" pitchFamily="34" charset="0"/>
+              <a:buChar char="•"/>
+            </a:pPr>
+            <a:r>
+              <a:rPr lang="en-US" sz="2000" dirty="0"/>
+              <a:t>Patterns are stable and spatially coherent</a:t>
+            </a:r>
+          </a:p>
+          <a:p>
+            <a:pPr marL="285750" indent="-285750">
+              <a:buFont typeface="Arial" panose="020B0604020202020204" pitchFamily="34" charset="0"/>
+              <a:buChar char="•"/>
+            </a:pPr>
+            <a:r>
+              <a:rPr lang="en-US" sz="2000" dirty="0"/>
+              <a:t>Similar municipalities cluster together </a:t>
+            </a:r>
+          </a:p>
+          <a:p>
+            <a:pPr marL="285750" indent="-285750">
+              <a:buFont typeface="Arial" panose="020B0604020202020204" pitchFamily="34" charset="0"/>
+              <a:buChar char="•"/>
+            </a:pPr>
+            <a:r>
+              <a:rPr lang="en-US" sz="2000" dirty="0"/>
+              <a:t>Neighboring regions share structural characteristics </a:t>
+            </a:r>
+          </a:p>
+          <a:p>
+            <a:pPr marL="285750" indent="-285750">
+              <a:buFont typeface="Arial" panose="020B0604020202020204" pitchFamily="34" charset="0"/>
+              <a:buChar char="•"/>
+            </a:pPr>
+            <a:r>
+              <a:rPr lang="en-US" sz="2000" dirty="0"/>
+              <a:t>Results are consistent across specifications </a:t>
+            </a:r>
+          </a:p>
+          <a:p>
+            <a:br>
+              <a:rPr lang="en-US" sz="2000" dirty="0"/>
+            </a:br>
+            <a:endParaRPr lang="en-US" sz="2000" dirty="0"/>
+          </a:p>
+          <a:p>
+            <a:r>
+              <a:rPr lang="en-US" sz="2000" b="1" dirty="0"/>
+              <a:t>Interpretation</a:t>
+            </a:r>
+          </a:p>
+          <a:p>
+            <a:pPr marL="285750" indent="-285750">
+              <a:buFont typeface="Arial" panose="020B0604020202020204" pitchFamily="34" charset="0"/>
+              <a:buChar char="•"/>
+            </a:pPr>
+            <a:r>
+              <a:rPr lang="en-US" sz="2000" dirty="0"/>
+              <a:t>Population dynamics are spatially structured, not random</a:t>
+            </a:r>
+          </a:p>
+          <a:p>
+            <a:pPr marL="285750" indent="-285750">
+              <a:buFont typeface="Arial" panose="020B0604020202020204" pitchFamily="34" charset="0"/>
+              <a:buChar char="•"/>
+            </a:pPr>
+            <a:r>
+              <a:rPr lang="en-US" sz="2000" dirty="0"/>
+              <a:t>Decline is concentrated in specific regions </a:t>
+            </a:r>
+          </a:p>
+          <a:p>
+            <a:pPr marL="285750" indent="-285750">
+              <a:buFont typeface="Arial" panose="020B0604020202020204" pitchFamily="34" charset="0"/>
+              <a:buChar char="•"/>
+            </a:pPr>
+            <a:r>
+              <a:rPr lang="en-US" sz="2000" dirty="0"/>
+              <a:t>Vulnerability and economic conditions align geographically</a:t>
+            </a:r>
+          </a:p>
+        </p:txBody>
+      </p:sp>
+    </p:spTree>
+    <p:extLst>
+      <p:ext uri="{BB962C8B-B14F-4D97-AF65-F5344CB8AC3E}">
+        <p14:creationId xmlns:p14="http://schemas.microsoft.com/office/powerpoint/2010/main" val="628415208"/>
+      </p:ext>
+    </p:extLst>
+  </p:cSld>
+  <p:clrMapOvr>
+    <a:masterClrMapping/>
+  </p:clrMapOvr>
+</p:sld>
+</file>
+
+<file path=ppt/slides/slide11.xml><?xml version="1.0" encoding="utf-8"?>
+<p:sld xmlns:a="http://schemas.openxmlformats.org/drawingml/2006/main" xmlns:r="http://schemas.openxmlformats.org/officeDocument/2006/relationships" xmlns:p="http://schemas.openxmlformats.org/presentationml/2006/main">
+  <p:cSld>
+    <p:spTree>
+      <p:nvGrpSpPr>
+        <p:cNvPr id="1" name="">
+          <a:extLst>
+            <a:ext uri="{FF2B5EF4-FFF2-40B4-BE49-F238E27FC236}">
               <a16:creationId xmlns:a16="http://schemas.microsoft.com/office/drawing/2014/main" id="{89901E96-4FBA-2C53-EB6D-71A73082909E}"/>
             </a:ext>
           </a:extLst>
@@ -8346,7 +8940,7 @@
 </p:sld>
 </file>
 
-<file path=ppt/slides/slide11.xml><?xml version="1.0" encoding="utf-8"?>
+<file path=ppt/slides/slide12.xml><?xml version="1.0" encoding="utf-8"?>
 <p:sld xmlns:a="http://schemas.openxmlformats.org/drawingml/2006/main" xmlns:r="http://schemas.openxmlformats.org/officeDocument/2006/relationships" xmlns:p="http://schemas.openxmlformats.org/presentationml/2006/main">
   <p:cSld>
     <p:spTree>
@@ -8528,7 +9122,7 @@
 </p:sld>
 </file>
 
-<file path=ppt/slides/slide12.xml><?xml version="1.0" encoding="utf-8"?>
+<file path=ppt/slides/slide13.xml><?xml version="1.0" encoding="utf-8"?>
 <p:sld xmlns:a="http://schemas.openxmlformats.org/drawingml/2006/main" xmlns:r="http://schemas.openxmlformats.org/officeDocument/2006/relationships" xmlns:p="http://schemas.openxmlformats.org/presentationml/2006/main">
   <p:cSld>
     <p:spTree>
@@ -8797,7 +9391,7 @@
 </p:sld>
 </file>
 
-<file path=ppt/slides/slide13.xml><?xml version="1.0" encoding="utf-8"?>
+<file path=ppt/slides/slide14.xml><?xml version="1.0" encoding="utf-8"?>
 <p:sld xmlns:a="http://schemas.openxmlformats.org/drawingml/2006/main" xmlns:r="http://schemas.openxmlformats.org/officeDocument/2006/relationships" xmlns:p="http://schemas.openxmlformats.org/presentationml/2006/main">
   <p:cSld>
     <p:spTree>
@@ -9078,7 +9672,7 @@
 </p:sld>
 </file>
 
-<file path=ppt/slides/slide14.xml><?xml version="1.0" encoding="utf-8"?>
+<file path=ppt/slides/slide15.xml><?xml version="1.0" encoding="utf-8"?>
 <p:sld xmlns:a="http://schemas.openxmlformats.org/drawingml/2006/main" xmlns:r="http://schemas.openxmlformats.org/officeDocument/2006/relationships" xmlns:p="http://schemas.openxmlformats.org/presentationml/2006/main">
   <p:cSld>
     <p:spTree>
@@ -9218,7 +9812,7 @@
 </p:sld>
 </file>
 
-<file path=ppt/slides/slide15.xml><?xml version="1.0" encoding="utf-8"?>
+<file path=ppt/slides/slide16.xml><?xml version="1.0" encoding="utf-8"?>
 <p:sld xmlns:a="http://schemas.openxmlformats.org/drawingml/2006/main" xmlns:r="http://schemas.openxmlformats.org/officeDocument/2006/relationships" xmlns:p="http://schemas.openxmlformats.org/presentationml/2006/main">
   <p:cSld>
     <p:spTree>
@@ -9664,7 +10258,7 @@
 </p:sld>
 </file>
 
-<file path=ppt/slides/slide16.xml><?xml version="1.0" encoding="utf-8"?>
+<file path=ppt/slides/slide17.xml><?xml version="1.0" encoding="utf-8"?>
 <p:sld xmlns:a="http://schemas.openxmlformats.org/drawingml/2006/main" xmlns:r="http://schemas.openxmlformats.org/officeDocument/2006/relationships" xmlns:p="http://schemas.openxmlformats.org/presentationml/2006/main">
   <p:cSld>
     <p:spTree>
@@ -10427,7 +11021,7 @@
 </p:sld>
 </file>
 
-<file path=ppt/slides/slide17.xml><?xml version="1.0" encoding="utf-8"?>
+<file path=ppt/slides/slide18.xml><?xml version="1.0" encoding="utf-8"?>
 <p:sld xmlns:a="http://schemas.openxmlformats.org/drawingml/2006/main" xmlns:r="http://schemas.openxmlformats.org/officeDocument/2006/relationships" xmlns:p="http://schemas.openxmlformats.org/presentationml/2006/main">
   <p:cSld>
     <p:spTree>
@@ -11857,7 +12451,7 @@
 </p:sld>
 </file>
 
-<file path=ppt/slides/slide18.xml><?xml version="1.0" encoding="utf-8"?>
+<file path=ppt/slides/slide19.xml><?xml version="1.0" encoding="utf-8"?>
 <p:sld xmlns:a="http://schemas.openxmlformats.org/drawingml/2006/main" xmlns:r="http://schemas.openxmlformats.org/officeDocument/2006/relationships" xmlns:p="http://schemas.openxmlformats.org/presentationml/2006/main">
   <p:cSld>
     <p:spTree>
@@ -12832,7 +13426,470 @@
 </p:sld>
 </file>
 
-<file path=ppt/slides/slide19.xml><?xml version="1.0" encoding="utf-8"?>
+<file path=ppt/slides/slide2.xml><?xml version="1.0" encoding="utf-8"?>
+<p:sld xmlns:a="http://schemas.openxmlformats.org/drawingml/2006/main" xmlns:r="http://schemas.openxmlformats.org/officeDocument/2006/relationships" xmlns:p="http://schemas.openxmlformats.org/presentationml/2006/main">
+  <p:cSld>
+    <p:spTree>
+      <p:nvGrpSpPr>
+        <p:cNvPr id="1" name=""/>
+        <p:cNvGrpSpPr/>
+        <p:nvPr/>
+      </p:nvGrpSpPr>
+      <p:grpSpPr>
+        <a:xfrm>
+          <a:off x="0" y="0"/>
+          <a:ext cx="0" cy="0"/>
+          <a:chOff x="0" y="0"/>
+          <a:chExt cx="0" cy="0"/>
+        </a:xfrm>
+      </p:grpSpPr>
+      <p:sp>
+        <p:nvSpPr>
+          <p:cNvPr id="4" name="Rectangle 3">
+            <a:extLst>
+              <a:ext uri="{FF2B5EF4-FFF2-40B4-BE49-F238E27FC236}">
+                <a16:creationId xmlns:a16="http://schemas.microsoft.com/office/drawing/2014/main" id="{BDECE9DE-5569-FB3D-9F3D-4B7D21E06AB8}"/>
+              </a:ext>
+            </a:extLst>
+          </p:cNvPr>
+          <p:cNvSpPr/>
+          <p:nvPr/>
+        </p:nvSpPr>
+        <p:spPr>
+          <a:xfrm>
+            <a:off x="0" y="196343"/>
+            <a:ext cx="7199290" cy="1007423"/>
+          </a:xfrm>
+          <a:prstGeom prst="rect">
+            <a:avLst/>
+          </a:prstGeom>
+          <a:solidFill>
+            <a:srgbClr val="CC0033"/>
+          </a:solidFill>
+          <a:ln>
+            <a:noFill/>
+          </a:ln>
+        </p:spPr>
+        <p:style>
+          <a:lnRef idx="1">
+            <a:schemeClr val="accent1"/>
+          </a:lnRef>
+          <a:fillRef idx="3">
+            <a:schemeClr val="accent1"/>
+          </a:fillRef>
+          <a:effectRef idx="2">
+            <a:schemeClr val="accent1"/>
+          </a:effectRef>
+          <a:fontRef idx="minor">
+            <a:schemeClr val="lt1"/>
+          </a:fontRef>
+        </p:style>
+        <p:txBody>
+          <a:bodyPr rtlCol="0" anchor="ctr"/>
+          <a:lstStyle/>
+          <a:p>
+            <a:pPr algn="ctr"/>
+            <a:endParaRPr lang="en-US" dirty="0">
+              <a:solidFill>
+                <a:schemeClr val="accent1"/>
+              </a:solidFill>
+            </a:endParaRPr>
+          </a:p>
+        </p:txBody>
+      </p:sp>
+      <p:sp>
+        <p:nvSpPr>
+          <p:cNvPr id="5" name="Title 10">
+            <a:extLst>
+              <a:ext uri="{FF2B5EF4-FFF2-40B4-BE49-F238E27FC236}">
+                <a16:creationId xmlns:a16="http://schemas.microsoft.com/office/drawing/2014/main" id="{F782AEBD-D968-67B5-44E1-E37D027F75E9}"/>
+              </a:ext>
+            </a:extLst>
+          </p:cNvPr>
+          <p:cNvSpPr txBox="1">
+            <a:spLocks/>
+          </p:cNvSpPr>
+          <p:nvPr/>
+        </p:nvSpPr>
+        <p:spPr>
+          <a:xfrm>
+            <a:off x="459357" y="361539"/>
+            <a:ext cx="6546750" cy="719563"/>
+          </a:xfrm>
+          <a:prstGeom prst="rect">
+            <a:avLst/>
+          </a:prstGeom>
+        </p:spPr>
+        <p:txBody>
+          <a:bodyPr anchor="ctr" anchorCtr="0">
+            <a:noAutofit/>
+          </a:bodyPr>
+          <a:lstStyle>
+            <a:lvl1pPr algn="ctr" defTabSz="457200" rtl="0" eaLnBrk="1" latinLnBrk="0" hangingPunct="1">
+              <a:spcBef>
+                <a:spcPct val="0"/>
+              </a:spcBef>
+              <a:buNone/>
+              <a:defRPr sz="4400" kern="1200">
+                <a:solidFill>
+                  <a:schemeClr val="tx1"/>
+                </a:solidFill>
+                <a:latin typeface="+mj-lt"/>
+                <a:ea typeface="+mj-ea"/>
+                <a:cs typeface="+mj-cs"/>
+              </a:defRPr>
+            </a:lvl1pPr>
+          </a:lstStyle>
+          <a:p>
+            <a:pPr lvl="0"/>
+            <a:r>
+              <a:rPr lang="en-US" b="1" dirty="0">
+                <a:solidFill>
+                  <a:schemeClr val="bg1"/>
+                </a:solidFill>
+              </a:rPr>
+              <a:t>Problem &amp; Objective </a:t>
+            </a:r>
+          </a:p>
+        </p:txBody>
+      </p:sp>
+      <p:sp>
+        <p:nvSpPr>
+          <p:cNvPr id="11" name="TextBox 10">
+            <a:extLst>
+              <a:ext uri="{FF2B5EF4-FFF2-40B4-BE49-F238E27FC236}">
+                <a16:creationId xmlns:a16="http://schemas.microsoft.com/office/drawing/2014/main" id="{39E0F022-DCC0-E84E-EDEB-7B39259B385C}"/>
+              </a:ext>
+            </a:extLst>
+          </p:cNvPr>
+          <p:cNvSpPr txBox="1"/>
+          <p:nvPr/>
+        </p:nvSpPr>
+        <p:spPr>
+          <a:xfrm>
+            <a:off x="139613" y="1368962"/>
+            <a:ext cx="11484828" cy="5247590"/>
+          </a:xfrm>
+          <a:prstGeom prst="rect">
+            <a:avLst/>
+          </a:prstGeom>
+          <a:noFill/>
+        </p:spPr>
+        <p:txBody>
+          <a:bodyPr wrap="square">
+            <a:spAutoFit/>
+          </a:bodyPr>
+          <a:lstStyle/>
+          <a:p>
+            <a:pPr marL="285750" indent="-285750" fontAlgn="base">
+              <a:lnSpc>
+                <a:spcPct val="150000"/>
+              </a:lnSpc>
+              <a:buFont typeface="Arial" panose="020B0604020202020204" pitchFamily="34" charset="0"/>
+              <a:buChar char="•"/>
+            </a:pPr>
+            <a:r>
+              <a:rPr lang="en-US" sz="1400" b="1" dirty="0">
+                <a:latin typeface="Merriweather" pitchFamily="2" charset="77"/>
+              </a:rPr>
+              <a:t>Research Problem: </a:t>
+            </a:r>
+            <a:r>
+              <a:rPr lang="en-US" sz="1400" dirty="0">
+                <a:latin typeface="Merriweather" pitchFamily="2" charset="77"/>
+              </a:rPr>
+              <a:t>Puerto Rico has experienced </a:t>
+            </a:r>
+            <a:r>
+              <a:rPr lang="en-US" sz="1400" i="1" dirty="0">
+                <a:latin typeface="Merriweather" pitchFamily="2" charset="77"/>
+              </a:rPr>
+              <a:t>significant population decline and regional vulnerability </a:t>
+            </a:r>
+            <a:r>
+              <a:rPr lang="en-US" sz="1400" dirty="0">
+                <a:latin typeface="Merriweather" pitchFamily="2" charset="77"/>
+              </a:rPr>
+              <a:t>driven by economic conditions, natural disasters, and social factors</a:t>
+            </a:r>
+          </a:p>
+          <a:p>
+            <a:pPr marL="285750" indent="-285750" fontAlgn="base">
+              <a:lnSpc>
+                <a:spcPct val="150000"/>
+              </a:lnSpc>
+              <a:buFont typeface="Arial" panose="020B0604020202020204" pitchFamily="34" charset="0"/>
+              <a:buChar char="•"/>
+            </a:pPr>
+            <a:endParaRPr lang="en-US" sz="1400" dirty="0">
+              <a:latin typeface="Merriweather" pitchFamily="2" charset="77"/>
+            </a:endParaRPr>
+          </a:p>
+          <a:p>
+            <a:pPr marL="285750" indent="-285750" fontAlgn="base">
+              <a:lnSpc>
+                <a:spcPct val="150000"/>
+              </a:lnSpc>
+              <a:buFont typeface="Arial" panose="020B0604020202020204" pitchFamily="34" charset="0"/>
+              <a:buChar char="•"/>
+            </a:pPr>
+            <a:r>
+              <a:rPr lang="en-US" sz="1400" b="1" dirty="0">
+                <a:latin typeface="Merriweather" pitchFamily="2" charset="77"/>
+              </a:rPr>
+              <a:t>Objective: </a:t>
+            </a:r>
+            <a:r>
+              <a:rPr lang="en-US" sz="1400" dirty="0">
+                <a:latin typeface="Merriweather" pitchFamily="2" charset="77"/>
+              </a:rPr>
+              <a:t>Develop a </a:t>
+            </a:r>
+            <a:r>
+              <a:rPr lang="en-US" sz="1400" b="1" i="1" dirty="0">
+                <a:latin typeface="Merriweather" pitchFamily="2" charset="77"/>
+              </a:rPr>
+              <a:t>data-driven framework</a:t>
+            </a:r>
+            <a:r>
+              <a:rPr lang="en-US" sz="1400" i="1" dirty="0">
+                <a:latin typeface="Merriweather" pitchFamily="2" charset="77"/>
+              </a:rPr>
+              <a:t> </a:t>
+            </a:r>
+            <a:r>
+              <a:rPr lang="en-US" sz="1400" dirty="0">
+                <a:latin typeface="Merriweather" pitchFamily="2" charset="77"/>
+              </a:rPr>
+              <a:t>to:</a:t>
+            </a:r>
+          </a:p>
+          <a:p>
+            <a:pPr marL="742950" lvl="1" indent="-285750" fontAlgn="base">
+              <a:lnSpc>
+                <a:spcPct val="150000"/>
+              </a:lnSpc>
+              <a:buFont typeface="Arial" panose="020B0604020202020204" pitchFamily="34" charset="0"/>
+              <a:buChar char="•"/>
+            </a:pPr>
+            <a:r>
+              <a:rPr lang="en-US" sz="1400" dirty="0">
+                <a:latin typeface="Merriweather" pitchFamily="2" charset="77"/>
+              </a:rPr>
+              <a:t>Model municipal and regional population change</a:t>
+            </a:r>
+          </a:p>
+          <a:p>
+            <a:pPr marL="742950" lvl="1" indent="-285750" fontAlgn="base">
+              <a:lnSpc>
+                <a:spcPct val="150000"/>
+              </a:lnSpc>
+              <a:buFont typeface="Arial" panose="020B0604020202020204" pitchFamily="34" charset="0"/>
+              <a:buChar char="•"/>
+            </a:pPr>
+            <a:r>
+              <a:rPr lang="en-US" sz="1400" dirty="0">
+                <a:latin typeface="Merriweather" pitchFamily="2" charset="77"/>
+              </a:rPr>
+              <a:t>Identify drivers of demographic decline</a:t>
+            </a:r>
+          </a:p>
+          <a:p>
+            <a:pPr marL="742950" lvl="1" indent="-285750" fontAlgn="base">
+              <a:lnSpc>
+                <a:spcPct val="150000"/>
+              </a:lnSpc>
+              <a:buFont typeface="Arial" panose="020B0604020202020204" pitchFamily="34" charset="0"/>
+              <a:buChar char="•"/>
+            </a:pPr>
+            <a:r>
+              <a:rPr lang="en-US" sz="1400" dirty="0">
+                <a:latin typeface="Merriweather" pitchFamily="2" charset="77"/>
+              </a:rPr>
+              <a:t>Detect structural municipal vulnerability patterns</a:t>
+            </a:r>
+          </a:p>
+          <a:p>
+            <a:pPr marL="742950" lvl="1" indent="-285750" fontAlgn="base">
+              <a:lnSpc>
+                <a:spcPct val="150000"/>
+              </a:lnSpc>
+              <a:buFont typeface="Arial" panose="020B0604020202020204" pitchFamily="34" charset="0"/>
+              <a:buChar char="•"/>
+            </a:pPr>
+            <a:r>
+              <a:rPr lang="en-US" sz="1400" dirty="0">
+                <a:latin typeface="Merriweather" pitchFamily="2" charset="77"/>
+              </a:rPr>
+              <a:t>Produce population forecasts and typologies</a:t>
+            </a:r>
+          </a:p>
+          <a:p>
+            <a:pPr marL="742950" lvl="1" indent="-285750" fontAlgn="base">
+              <a:lnSpc>
+                <a:spcPct val="150000"/>
+              </a:lnSpc>
+              <a:buFont typeface="Arial" panose="020B0604020202020204" pitchFamily="34" charset="0"/>
+              <a:buChar char="•"/>
+            </a:pPr>
+            <a:endParaRPr lang="en-US" sz="1400" dirty="0">
+              <a:latin typeface="Merriweather" pitchFamily="2" charset="77"/>
+            </a:endParaRPr>
+          </a:p>
+          <a:p>
+            <a:pPr marL="285750" indent="-285750" fontAlgn="base">
+              <a:lnSpc>
+                <a:spcPct val="150000"/>
+              </a:lnSpc>
+              <a:buFont typeface="Arial" panose="020B0604020202020204" pitchFamily="34" charset="0"/>
+              <a:buChar char="•"/>
+            </a:pPr>
+            <a:r>
+              <a:rPr lang="en-US" sz="1400" b="1" dirty="0">
+                <a:latin typeface="Merriweather" pitchFamily="2" charset="77"/>
+              </a:rPr>
+              <a:t>Success Criteria</a:t>
+            </a:r>
+          </a:p>
+          <a:p>
+            <a:pPr marL="742950" lvl="1" indent="-285750" fontAlgn="base">
+              <a:lnSpc>
+                <a:spcPct val="150000"/>
+              </a:lnSpc>
+              <a:buFont typeface="Arial" panose="020B0604020202020204" pitchFamily="34" charset="0"/>
+              <a:buChar char="•"/>
+            </a:pPr>
+            <a:r>
+              <a:rPr lang="en-US" sz="1400" dirty="0">
+                <a:latin typeface="Merriweather" pitchFamily="2" charset="77"/>
+              </a:rPr>
+              <a:t>Predict population change with reasonable accuracy</a:t>
+            </a:r>
+          </a:p>
+          <a:p>
+            <a:pPr marL="742950" lvl="1" indent="-285750" fontAlgn="base">
+              <a:lnSpc>
+                <a:spcPct val="150000"/>
+              </a:lnSpc>
+              <a:buFont typeface="Arial" panose="020B0604020202020204" pitchFamily="34" charset="0"/>
+              <a:buChar char="•"/>
+            </a:pPr>
+            <a:r>
+              <a:rPr lang="en-US" sz="1400" dirty="0">
+                <a:latin typeface="Merriweather" pitchFamily="2" charset="77"/>
+              </a:rPr>
+              <a:t>Identify key drivers </a:t>
+            </a:r>
+          </a:p>
+          <a:p>
+            <a:pPr marL="742950" lvl="1" indent="-285750" fontAlgn="base">
+              <a:lnSpc>
+                <a:spcPct val="150000"/>
+              </a:lnSpc>
+              <a:buFont typeface="Arial" panose="020B0604020202020204" pitchFamily="34" charset="0"/>
+              <a:buChar char="•"/>
+            </a:pPr>
+            <a:r>
+              <a:rPr lang="en-US" sz="1400" dirty="0">
+                <a:latin typeface="Merriweather" pitchFamily="2" charset="77"/>
+              </a:rPr>
+              <a:t>Detect clusters/regions with similar vulnerability profiles</a:t>
+            </a:r>
+          </a:p>
+          <a:p>
+            <a:pPr marL="742950" lvl="1" indent="-285750" fontAlgn="base">
+              <a:lnSpc>
+                <a:spcPct val="150000"/>
+              </a:lnSpc>
+              <a:buFont typeface="Arial" panose="020B0604020202020204" pitchFamily="34" charset="0"/>
+              <a:buChar char="•"/>
+            </a:pPr>
+            <a:endParaRPr lang="en-US" sz="1400" dirty="0">
+              <a:latin typeface="Merriweather" pitchFamily="2" charset="77"/>
+            </a:endParaRPr>
+          </a:p>
+          <a:p>
+            <a:pPr marL="285750" indent="-285750" fontAlgn="base">
+              <a:lnSpc>
+                <a:spcPct val="150000"/>
+              </a:lnSpc>
+              <a:buFont typeface="Arial" panose="020B0604020202020204" pitchFamily="34" charset="0"/>
+              <a:buChar char="•"/>
+            </a:pPr>
+            <a:r>
+              <a:rPr lang="en-US" sz="1400" b="1" dirty="0">
+                <a:latin typeface="Merriweather" pitchFamily="2" charset="77"/>
+              </a:rPr>
+              <a:t>This week, I worked on extend modeling to scenario-based forecasting under disasters</a:t>
+            </a:r>
+          </a:p>
+          <a:p>
+            <a:pPr marL="285750" indent="-285750" fontAlgn="base">
+              <a:buFont typeface="Arial" panose="020B0604020202020204" pitchFamily="34" charset="0"/>
+              <a:buChar char="•"/>
+            </a:pPr>
+            <a:endParaRPr lang="en-US" sz="1400" dirty="0">
+              <a:solidFill>
+                <a:srgbClr val="000000"/>
+              </a:solidFill>
+              <a:latin typeface="Merriweather" pitchFamily="2" charset="77"/>
+              <a:ea typeface="Arial"/>
+              <a:cs typeface="Arial"/>
+              <a:sym typeface="Arial"/>
+            </a:endParaRPr>
+          </a:p>
+        </p:txBody>
+      </p:sp>
+      <p:pic>
+        <p:nvPicPr>
+          <p:cNvPr id="9" name="Picture 8" descr="A map of puerto rico with a graph and a chart&#10;&#10;AI-generated content may be incorrect.">
+            <a:extLst>
+              <a:ext uri="{FF2B5EF4-FFF2-40B4-BE49-F238E27FC236}">
+                <a16:creationId xmlns:a16="http://schemas.microsoft.com/office/drawing/2014/main" id="{127A0D1B-B23D-7AB3-2172-9CE8952C180B}"/>
+              </a:ext>
+            </a:extLst>
+          </p:cNvPr>
+          <p:cNvPicPr>
+            <a:picLocks noChangeAspect="1"/>
+          </p:cNvPicPr>
+          <p:nvPr/>
+        </p:nvPicPr>
+        <p:blipFill>
+          <a:blip r:embed="rId2">
+            <a:extLst>
+              <a:ext uri="{28A0092B-C50C-407E-A947-70E740481C1C}">
+                <a14:useLocalDpi xmlns:a14="http://schemas.microsoft.com/office/drawing/2010/main" val="0"/>
+              </a:ext>
+            </a:extLst>
+          </a:blip>
+          <a:stretch>
+            <a:fillRect/>
+          </a:stretch>
+        </p:blipFill>
+        <p:spPr>
+          <a:xfrm>
+            <a:off x="6888987" y="2052133"/>
+            <a:ext cx="4517551" cy="3316132"/>
+          </a:xfrm>
+          <a:prstGeom prst="rect">
+            <a:avLst/>
+          </a:prstGeom>
+        </p:spPr>
+      </p:pic>
+    </p:spTree>
+    <p:extLst>
+      <p:ext uri="{BB962C8B-B14F-4D97-AF65-F5344CB8AC3E}">
+        <p14:creationId xmlns:p14="http://schemas.microsoft.com/office/powerpoint/2010/main" val="356348516"/>
+      </p:ext>
+    </p:extLst>
+  </p:cSld>
+  <p:clrMapOvr>
+    <a:masterClrMapping/>
+  </p:clrMapOvr>
+</p:sld>
+</file>
+
+<file path=ppt/slides/slide20.xml><?xml version="1.0" encoding="utf-8"?>
 <p:sld xmlns:a="http://schemas.openxmlformats.org/drawingml/2006/main" xmlns:r="http://schemas.openxmlformats.org/officeDocument/2006/relationships" xmlns:p="http://schemas.openxmlformats.org/presentationml/2006/main">
   <p:cSld>
     <p:spTree>
@@ -13890,470 +14947,7 @@
 </p:sld>
 </file>
 
-<file path=ppt/slides/slide2.xml><?xml version="1.0" encoding="utf-8"?>
-<p:sld xmlns:a="http://schemas.openxmlformats.org/drawingml/2006/main" xmlns:r="http://schemas.openxmlformats.org/officeDocument/2006/relationships" xmlns:p="http://schemas.openxmlformats.org/presentationml/2006/main">
-  <p:cSld>
-    <p:spTree>
-      <p:nvGrpSpPr>
-        <p:cNvPr id="1" name=""/>
-        <p:cNvGrpSpPr/>
-        <p:nvPr/>
-      </p:nvGrpSpPr>
-      <p:grpSpPr>
-        <a:xfrm>
-          <a:off x="0" y="0"/>
-          <a:ext cx="0" cy="0"/>
-          <a:chOff x="0" y="0"/>
-          <a:chExt cx="0" cy="0"/>
-        </a:xfrm>
-      </p:grpSpPr>
-      <p:sp>
-        <p:nvSpPr>
-          <p:cNvPr id="4" name="Rectangle 3">
-            <a:extLst>
-              <a:ext uri="{FF2B5EF4-FFF2-40B4-BE49-F238E27FC236}">
-                <a16:creationId xmlns:a16="http://schemas.microsoft.com/office/drawing/2014/main" id="{BDECE9DE-5569-FB3D-9F3D-4B7D21E06AB8}"/>
-              </a:ext>
-            </a:extLst>
-          </p:cNvPr>
-          <p:cNvSpPr/>
-          <p:nvPr/>
-        </p:nvSpPr>
-        <p:spPr>
-          <a:xfrm>
-            <a:off x="0" y="196343"/>
-            <a:ext cx="7199290" cy="1007423"/>
-          </a:xfrm>
-          <a:prstGeom prst="rect">
-            <a:avLst/>
-          </a:prstGeom>
-          <a:solidFill>
-            <a:srgbClr val="CC0033"/>
-          </a:solidFill>
-          <a:ln>
-            <a:noFill/>
-          </a:ln>
-        </p:spPr>
-        <p:style>
-          <a:lnRef idx="1">
-            <a:schemeClr val="accent1"/>
-          </a:lnRef>
-          <a:fillRef idx="3">
-            <a:schemeClr val="accent1"/>
-          </a:fillRef>
-          <a:effectRef idx="2">
-            <a:schemeClr val="accent1"/>
-          </a:effectRef>
-          <a:fontRef idx="minor">
-            <a:schemeClr val="lt1"/>
-          </a:fontRef>
-        </p:style>
-        <p:txBody>
-          <a:bodyPr rtlCol="0" anchor="ctr"/>
-          <a:lstStyle/>
-          <a:p>
-            <a:pPr algn="ctr"/>
-            <a:endParaRPr lang="en-US" dirty="0">
-              <a:solidFill>
-                <a:schemeClr val="accent1"/>
-              </a:solidFill>
-            </a:endParaRPr>
-          </a:p>
-        </p:txBody>
-      </p:sp>
-      <p:sp>
-        <p:nvSpPr>
-          <p:cNvPr id="5" name="Title 10">
-            <a:extLst>
-              <a:ext uri="{FF2B5EF4-FFF2-40B4-BE49-F238E27FC236}">
-                <a16:creationId xmlns:a16="http://schemas.microsoft.com/office/drawing/2014/main" id="{F782AEBD-D968-67B5-44E1-E37D027F75E9}"/>
-              </a:ext>
-            </a:extLst>
-          </p:cNvPr>
-          <p:cNvSpPr txBox="1">
-            <a:spLocks/>
-          </p:cNvSpPr>
-          <p:nvPr/>
-        </p:nvSpPr>
-        <p:spPr>
-          <a:xfrm>
-            <a:off x="459357" y="361539"/>
-            <a:ext cx="6546750" cy="719563"/>
-          </a:xfrm>
-          <a:prstGeom prst="rect">
-            <a:avLst/>
-          </a:prstGeom>
-        </p:spPr>
-        <p:txBody>
-          <a:bodyPr anchor="ctr" anchorCtr="0">
-            <a:noAutofit/>
-          </a:bodyPr>
-          <a:lstStyle>
-            <a:lvl1pPr algn="ctr" defTabSz="457200" rtl="0" eaLnBrk="1" latinLnBrk="0" hangingPunct="1">
-              <a:spcBef>
-                <a:spcPct val="0"/>
-              </a:spcBef>
-              <a:buNone/>
-              <a:defRPr sz="4400" kern="1200">
-                <a:solidFill>
-                  <a:schemeClr val="tx1"/>
-                </a:solidFill>
-                <a:latin typeface="+mj-lt"/>
-                <a:ea typeface="+mj-ea"/>
-                <a:cs typeface="+mj-cs"/>
-              </a:defRPr>
-            </a:lvl1pPr>
-          </a:lstStyle>
-          <a:p>
-            <a:pPr lvl="0"/>
-            <a:r>
-              <a:rPr lang="en-US" b="1" dirty="0">
-                <a:solidFill>
-                  <a:schemeClr val="bg1"/>
-                </a:solidFill>
-              </a:rPr>
-              <a:t>Problem &amp; Objective </a:t>
-            </a:r>
-          </a:p>
-        </p:txBody>
-      </p:sp>
-      <p:sp>
-        <p:nvSpPr>
-          <p:cNvPr id="11" name="TextBox 10">
-            <a:extLst>
-              <a:ext uri="{FF2B5EF4-FFF2-40B4-BE49-F238E27FC236}">
-                <a16:creationId xmlns:a16="http://schemas.microsoft.com/office/drawing/2014/main" id="{39E0F022-DCC0-E84E-EDEB-7B39259B385C}"/>
-              </a:ext>
-            </a:extLst>
-          </p:cNvPr>
-          <p:cNvSpPr txBox="1"/>
-          <p:nvPr/>
-        </p:nvSpPr>
-        <p:spPr>
-          <a:xfrm>
-            <a:off x="139613" y="1368962"/>
-            <a:ext cx="11484828" cy="5247590"/>
-          </a:xfrm>
-          <a:prstGeom prst="rect">
-            <a:avLst/>
-          </a:prstGeom>
-          <a:noFill/>
-        </p:spPr>
-        <p:txBody>
-          <a:bodyPr wrap="square">
-            <a:spAutoFit/>
-          </a:bodyPr>
-          <a:lstStyle/>
-          <a:p>
-            <a:pPr marL="285750" indent="-285750" fontAlgn="base">
-              <a:lnSpc>
-                <a:spcPct val="150000"/>
-              </a:lnSpc>
-              <a:buFont typeface="Arial" panose="020B0604020202020204" pitchFamily="34" charset="0"/>
-              <a:buChar char="•"/>
-            </a:pPr>
-            <a:r>
-              <a:rPr lang="en-US" sz="1400" b="1" dirty="0">
-                <a:latin typeface="Merriweather" pitchFamily="2" charset="77"/>
-              </a:rPr>
-              <a:t>Research Problem: </a:t>
-            </a:r>
-            <a:r>
-              <a:rPr lang="en-US" sz="1400" dirty="0">
-                <a:latin typeface="Merriweather" pitchFamily="2" charset="77"/>
-              </a:rPr>
-              <a:t>Puerto Rico has experienced </a:t>
-            </a:r>
-            <a:r>
-              <a:rPr lang="en-US" sz="1400" i="1" dirty="0">
-                <a:latin typeface="Merriweather" pitchFamily="2" charset="77"/>
-              </a:rPr>
-              <a:t>significant population decline and regional vulnerability </a:t>
-            </a:r>
-            <a:r>
-              <a:rPr lang="en-US" sz="1400" dirty="0">
-                <a:latin typeface="Merriweather" pitchFamily="2" charset="77"/>
-              </a:rPr>
-              <a:t>driven by economic conditions, natural disasters, and social factors</a:t>
-            </a:r>
-          </a:p>
-          <a:p>
-            <a:pPr marL="285750" indent="-285750" fontAlgn="base">
-              <a:lnSpc>
-                <a:spcPct val="150000"/>
-              </a:lnSpc>
-              <a:buFont typeface="Arial" panose="020B0604020202020204" pitchFamily="34" charset="0"/>
-              <a:buChar char="•"/>
-            </a:pPr>
-            <a:endParaRPr lang="en-US" sz="1400" dirty="0">
-              <a:latin typeface="Merriweather" pitchFamily="2" charset="77"/>
-            </a:endParaRPr>
-          </a:p>
-          <a:p>
-            <a:pPr marL="285750" indent="-285750" fontAlgn="base">
-              <a:lnSpc>
-                <a:spcPct val="150000"/>
-              </a:lnSpc>
-              <a:buFont typeface="Arial" panose="020B0604020202020204" pitchFamily="34" charset="0"/>
-              <a:buChar char="•"/>
-            </a:pPr>
-            <a:r>
-              <a:rPr lang="en-US" sz="1400" b="1" dirty="0">
-                <a:latin typeface="Merriweather" pitchFamily="2" charset="77"/>
-              </a:rPr>
-              <a:t>Objective: </a:t>
-            </a:r>
-            <a:r>
-              <a:rPr lang="en-US" sz="1400" dirty="0">
-                <a:latin typeface="Merriweather" pitchFamily="2" charset="77"/>
-              </a:rPr>
-              <a:t>Develop a </a:t>
-            </a:r>
-            <a:r>
-              <a:rPr lang="en-US" sz="1400" b="1" i="1" dirty="0">
-                <a:latin typeface="Merriweather" pitchFamily="2" charset="77"/>
-              </a:rPr>
-              <a:t>data-driven framework</a:t>
-            </a:r>
-            <a:r>
-              <a:rPr lang="en-US" sz="1400" i="1" dirty="0">
-                <a:latin typeface="Merriweather" pitchFamily="2" charset="77"/>
-              </a:rPr>
-              <a:t> </a:t>
-            </a:r>
-            <a:r>
-              <a:rPr lang="en-US" sz="1400" dirty="0">
-                <a:latin typeface="Merriweather" pitchFamily="2" charset="77"/>
-              </a:rPr>
-              <a:t>to:</a:t>
-            </a:r>
-          </a:p>
-          <a:p>
-            <a:pPr marL="742950" lvl="1" indent="-285750" fontAlgn="base">
-              <a:lnSpc>
-                <a:spcPct val="150000"/>
-              </a:lnSpc>
-              <a:buFont typeface="Arial" panose="020B0604020202020204" pitchFamily="34" charset="0"/>
-              <a:buChar char="•"/>
-            </a:pPr>
-            <a:r>
-              <a:rPr lang="en-US" sz="1400" dirty="0">
-                <a:latin typeface="Merriweather" pitchFamily="2" charset="77"/>
-              </a:rPr>
-              <a:t>Model municipal and regional population change</a:t>
-            </a:r>
-          </a:p>
-          <a:p>
-            <a:pPr marL="742950" lvl="1" indent="-285750" fontAlgn="base">
-              <a:lnSpc>
-                <a:spcPct val="150000"/>
-              </a:lnSpc>
-              <a:buFont typeface="Arial" panose="020B0604020202020204" pitchFamily="34" charset="0"/>
-              <a:buChar char="•"/>
-            </a:pPr>
-            <a:r>
-              <a:rPr lang="en-US" sz="1400" dirty="0">
-                <a:latin typeface="Merriweather" pitchFamily="2" charset="77"/>
-              </a:rPr>
-              <a:t>Identify drivers of demographic decline</a:t>
-            </a:r>
-          </a:p>
-          <a:p>
-            <a:pPr marL="742950" lvl="1" indent="-285750" fontAlgn="base">
-              <a:lnSpc>
-                <a:spcPct val="150000"/>
-              </a:lnSpc>
-              <a:buFont typeface="Arial" panose="020B0604020202020204" pitchFamily="34" charset="0"/>
-              <a:buChar char="•"/>
-            </a:pPr>
-            <a:r>
-              <a:rPr lang="en-US" sz="1400" dirty="0">
-                <a:latin typeface="Merriweather" pitchFamily="2" charset="77"/>
-              </a:rPr>
-              <a:t>Detect structural municipal vulnerability patterns</a:t>
-            </a:r>
-          </a:p>
-          <a:p>
-            <a:pPr marL="742950" lvl="1" indent="-285750" fontAlgn="base">
-              <a:lnSpc>
-                <a:spcPct val="150000"/>
-              </a:lnSpc>
-              <a:buFont typeface="Arial" panose="020B0604020202020204" pitchFamily="34" charset="0"/>
-              <a:buChar char="•"/>
-            </a:pPr>
-            <a:r>
-              <a:rPr lang="en-US" sz="1400" dirty="0">
-                <a:latin typeface="Merriweather" pitchFamily="2" charset="77"/>
-              </a:rPr>
-              <a:t>Produce population forecasts and typologies</a:t>
-            </a:r>
-          </a:p>
-          <a:p>
-            <a:pPr marL="742950" lvl="1" indent="-285750" fontAlgn="base">
-              <a:lnSpc>
-                <a:spcPct val="150000"/>
-              </a:lnSpc>
-              <a:buFont typeface="Arial" panose="020B0604020202020204" pitchFamily="34" charset="0"/>
-              <a:buChar char="•"/>
-            </a:pPr>
-            <a:endParaRPr lang="en-US" sz="1400" dirty="0">
-              <a:latin typeface="Merriweather" pitchFamily="2" charset="77"/>
-            </a:endParaRPr>
-          </a:p>
-          <a:p>
-            <a:pPr marL="285750" indent="-285750" fontAlgn="base">
-              <a:lnSpc>
-                <a:spcPct val="150000"/>
-              </a:lnSpc>
-              <a:buFont typeface="Arial" panose="020B0604020202020204" pitchFamily="34" charset="0"/>
-              <a:buChar char="•"/>
-            </a:pPr>
-            <a:r>
-              <a:rPr lang="en-US" sz="1400" b="1" dirty="0">
-                <a:latin typeface="Merriweather" pitchFamily="2" charset="77"/>
-              </a:rPr>
-              <a:t>Success Criteria</a:t>
-            </a:r>
-          </a:p>
-          <a:p>
-            <a:pPr marL="742950" lvl="1" indent="-285750" fontAlgn="base">
-              <a:lnSpc>
-                <a:spcPct val="150000"/>
-              </a:lnSpc>
-              <a:buFont typeface="Arial" panose="020B0604020202020204" pitchFamily="34" charset="0"/>
-              <a:buChar char="•"/>
-            </a:pPr>
-            <a:r>
-              <a:rPr lang="en-US" sz="1400" dirty="0">
-                <a:latin typeface="Merriweather" pitchFamily="2" charset="77"/>
-              </a:rPr>
-              <a:t>Predict population change with reasonable accuracy</a:t>
-            </a:r>
-          </a:p>
-          <a:p>
-            <a:pPr marL="742950" lvl="1" indent="-285750" fontAlgn="base">
-              <a:lnSpc>
-                <a:spcPct val="150000"/>
-              </a:lnSpc>
-              <a:buFont typeface="Arial" panose="020B0604020202020204" pitchFamily="34" charset="0"/>
-              <a:buChar char="•"/>
-            </a:pPr>
-            <a:r>
-              <a:rPr lang="en-US" sz="1400" dirty="0">
-                <a:latin typeface="Merriweather" pitchFamily="2" charset="77"/>
-              </a:rPr>
-              <a:t>Identify key drivers </a:t>
-            </a:r>
-          </a:p>
-          <a:p>
-            <a:pPr marL="742950" lvl="1" indent="-285750" fontAlgn="base">
-              <a:lnSpc>
-                <a:spcPct val="150000"/>
-              </a:lnSpc>
-              <a:buFont typeface="Arial" panose="020B0604020202020204" pitchFamily="34" charset="0"/>
-              <a:buChar char="•"/>
-            </a:pPr>
-            <a:r>
-              <a:rPr lang="en-US" sz="1400" dirty="0">
-                <a:latin typeface="Merriweather" pitchFamily="2" charset="77"/>
-              </a:rPr>
-              <a:t>Detect clusters/regions with similar vulnerability profiles</a:t>
-            </a:r>
-          </a:p>
-          <a:p>
-            <a:pPr marL="742950" lvl="1" indent="-285750" fontAlgn="base">
-              <a:lnSpc>
-                <a:spcPct val="150000"/>
-              </a:lnSpc>
-              <a:buFont typeface="Arial" panose="020B0604020202020204" pitchFamily="34" charset="0"/>
-              <a:buChar char="•"/>
-            </a:pPr>
-            <a:endParaRPr lang="en-US" sz="1400" dirty="0">
-              <a:latin typeface="Merriweather" pitchFamily="2" charset="77"/>
-            </a:endParaRPr>
-          </a:p>
-          <a:p>
-            <a:pPr marL="285750" indent="-285750" fontAlgn="base">
-              <a:lnSpc>
-                <a:spcPct val="150000"/>
-              </a:lnSpc>
-              <a:buFont typeface="Arial" panose="020B0604020202020204" pitchFamily="34" charset="0"/>
-              <a:buChar char="•"/>
-            </a:pPr>
-            <a:r>
-              <a:rPr lang="en-US" sz="1400" b="1" dirty="0">
-                <a:latin typeface="Merriweather" pitchFamily="2" charset="77"/>
-              </a:rPr>
-              <a:t>This week, I worked on extend modeling to scenario-based forecasting under disasters</a:t>
-            </a:r>
-          </a:p>
-          <a:p>
-            <a:pPr marL="285750" indent="-285750" fontAlgn="base">
-              <a:buFont typeface="Arial" panose="020B0604020202020204" pitchFamily="34" charset="0"/>
-              <a:buChar char="•"/>
-            </a:pPr>
-            <a:endParaRPr lang="en-US" sz="1400" dirty="0">
-              <a:solidFill>
-                <a:srgbClr val="000000"/>
-              </a:solidFill>
-              <a:latin typeface="Merriweather" pitchFamily="2" charset="77"/>
-              <a:ea typeface="Arial"/>
-              <a:cs typeface="Arial"/>
-              <a:sym typeface="Arial"/>
-            </a:endParaRPr>
-          </a:p>
-        </p:txBody>
-      </p:sp>
-      <p:pic>
-        <p:nvPicPr>
-          <p:cNvPr id="9" name="Picture 8" descr="A map of puerto rico with a graph and a chart&#10;&#10;AI-generated content may be incorrect.">
-            <a:extLst>
-              <a:ext uri="{FF2B5EF4-FFF2-40B4-BE49-F238E27FC236}">
-                <a16:creationId xmlns:a16="http://schemas.microsoft.com/office/drawing/2014/main" id="{127A0D1B-B23D-7AB3-2172-9CE8952C180B}"/>
-              </a:ext>
-            </a:extLst>
-          </p:cNvPr>
-          <p:cNvPicPr>
-            <a:picLocks noChangeAspect="1"/>
-          </p:cNvPicPr>
-          <p:nvPr/>
-        </p:nvPicPr>
-        <p:blipFill>
-          <a:blip r:embed="rId2">
-            <a:extLst>
-              <a:ext uri="{28A0092B-C50C-407E-A947-70E740481C1C}">
-                <a14:useLocalDpi xmlns:a14="http://schemas.microsoft.com/office/drawing/2010/main" val="0"/>
-              </a:ext>
-            </a:extLst>
-          </a:blip>
-          <a:stretch>
-            <a:fillRect/>
-          </a:stretch>
-        </p:blipFill>
-        <p:spPr>
-          <a:xfrm>
-            <a:off x="6888987" y="2052133"/>
-            <a:ext cx="4517551" cy="3316132"/>
-          </a:xfrm>
-          <a:prstGeom prst="rect">
-            <a:avLst/>
-          </a:prstGeom>
-        </p:spPr>
-      </p:pic>
-    </p:spTree>
-    <p:extLst>
-      <p:ext uri="{BB962C8B-B14F-4D97-AF65-F5344CB8AC3E}">
-        <p14:creationId xmlns:p14="http://schemas.microsoft.com/office/powerpoint/2010/main" val="356348516"/>
-      </p:ext>
-    </p:extLst>
-  </p:cSld>
-  <p:clrMapOvr>
-    <a:masterClrMapping/>
-  </p:clrMapOvr>
-</p:sld>
-</file>
-
-<file path=ppt/slides/slide20.xml><?xml version="1.0" encoding="utf-8"?>
+<file path=ppt/slides/slide21.xml><?xml version="1.0" encoding="utf-8"?>
 <p:sld xmlns:a="http://schemas.openxmlformats.org/drawingml/2006/main" xmlns:r="http://schemas.openxmlformats.org/officeDocument/2006/relationships" xmlns:p="http://schemas.openxmlformats.org/presentationml/2006/main">
   <p:cSld>
     <p:spTree>
@@ -15140,7 +15734,7 @@
 </p:sld>
 </file>
 
-<file path=ppt/slides/slide21.xml><?xml version="1.0" encoding="utf-8"?>
+<file path=ppt/slides/slide22.xml><?xml version="1.0" encoding="utf-8"?>
 <p:sld xmlns:a="http://schemas.openxmlformats.org/drawingml/2006/main" xmlns:r="http://schemas.openxmlformats.org/officeDocument/2006/relationships" xmlns:p="http://schemas.openxmlformats.org/presentationml/2006/main">
   <p:cSld>
     <p:spTree>
@@ -19670,6 +20264,350 @@
         <p:cNvPr id="1" name="">
           <a:extLst>
             <a:ext uri="{FF2B5EF4-FFF2-40B4-BE49-F238E27FC236}">
+              <a16:creationId xmlns:a16="http://schemas.microsoft.com/office/drawing/2014/main" id="{F898286B-27FC-B142-24DF-3360A23C1DF8}"/>
+            </a:ext>
+          </a:extLst>
+        </p:cNvPr>
+        <p:cNvGrpSpPr/>
+        <p:nvPr/>
+      </p:nvGrpSpPr>
+      <p:grpSpPr>
+        <a:xfrm>
+          <a:off x="0" y="0"/>
+          <a:ext cx="0" cy="0"/>
+          <a:chOff x="0" y="0"/>
+          <a:chExt cx="0" cy="0"/>
+        </a:xfrm>
+      </p:grpSpPr>
+      <p:sp>
+        <p:nvSpPr>
+          <p:cNvPr id="4" name="Rectangle 3">
+            <a:extLst>
+              <a:ext uri="{FF2B5EF4-FFF2-40B4-BE49-F238E27FC236}">
+                <a16:creationId xmlns:a16="http://schemas.microsoft.com/office/drawing/2014/main" id="{B8A85A02-485F-6DB0-7576-9AB1804B11B7}"/>
+              </a:ext>
+            </a:extLst>
+          </p:cNvPr>
+          <p:cNvSpPr/>
+          <p:nvPr/>
+        </p:nvSpPr>
+        <p:spPr>
+          <a:xfrm>
+            <a:off x="0" y="196343"/>
+            <a:ext cx="7199290" cy="1007423"/>
+          </a:xfrm>
+          <a:prstGeom prst="rect">
+            <a:avLst/>
+          </a:prstGeom>
+          <a:solidFill>
+            <a:srgbClr val="CC0033"/>
+          </a:solidFill>
+          <a:ln>
+            <a:noFill/>
+          </a:ln>
+        </p:spPr>
+        <p:style>
+          <a:lnRef idx="1">
+            <a:schemeClr val="accent1"/>
+          </a:lnRef>
+          <a:fillRef idx="3">
+            <a:schemeClr val="accent1"/>
+          </a:fillRef>
+          <a:effectRef idx="2">
+            <a:schemeClr val="accent1"/>
+          </a:effectRef>
+          <a:fontRef idx="minor">
+            <a:schemeClr val="lt1"/>
+          </a:fontRef>
+        </p:style>
+        <p:txBody>
+          <a:bodyPr rtlCol="0" anchor="ctr"/>
+          <a:lstStyle/>
+          <a:p>
+            <a:pPr algn="ctr"/>
+            <a:endParaRPr lang="en-US" dirty="0">
+              <a:solidFill>
+                <a:schemeClr val="accent1"/>
+              </a:solidFill>
+            </a:endParaRPr>
+          </a:p>
+        </p:txBody>
+      </p:sp>
+      <p:sp>
+        <p:nvSpPr>
+          <p:cNvPr id="5" name="Title 10">
+            <a:extLst>
+              <a:ext uri="{FF2B5EF4-FFF2-40B4-BE49-F238E27FC236}">
+                <a16:creationId xmlns:a16="http://schemas.microsoft.com/office/drawing/2014/main" id="{A41ABC40-ED9C-119F-A258-0124DEB857C6}"/>
+              </a:ext>
+            </a:extLst>
+          </p:cNvPr>
+          <p:cNvSpPr txBox="1">
+            <a:spLocks/>
+          </p:cNvSpPr>
+          <p:nvPr/>
+        </p:nvSpPr>
+        <p:spPr>
+          <a:xfrm>
+            <a:off x="0" y="361539"/>
+            <a:ext cx="7199289" cy="719563"/>
+          </a:xfrm>
+          <a:prstGeom prst="rect">
+            <a:avLst/>
+          </a:prstGeom>
+        </p:spPr>
+        <p:txBody>
+          <a:bodyPr anchor="ctr" anchorCtr="0">
+            <a:noAutofit/>
+          </a:bodyPr>
+          <a:lstStyle>
+            <a:lvl1pPr algn="ctr" defTabSz="457200" rtl="0" eaLnBrk="1" latinLnBrk="0" hangingPunct="1">
+              <a:spcBef>
+                <a:spcPct val="0"/>
+              </a:spcBef>
+              <a:buNone/>
+              <a:defRPr sz="4400" kern="1200">
+                <a:solidFill>
+                  <a:schemeClr val="tx1"/>
+                </a:solidFill>
+                <a:latin typeface="+mj-lt"/>
+                <a:ea typeface="+mj-ea"/>
+                <a:cs typeface="+mj-cs"/>
+              </a:defRPr>
+            </a:lvl1pPr>
+          </a:lstStyle>
+          <a:p>
+            <a:pPr lvl="0"/>
+            <a:r>
+              <a:rPr lang="en-US" sz="3200" b="1" dirty="0">
+                <a:solidFill>
+                  <a:schemeClr val="bg1"/>
+                </a:solidFill>
+              </a:rPr>
+              <a:t>Lead–Lag Analysis: </a:t>
+            </a:r>
+          </a:p>
+          <a:p>
+            <a:pPr lvl="0"/>
+            <a:r>
+              <a:rPr lang="en-US" sz="3200" b="1" dirty="0">
+                <a:solidFill>
+                  <a:schemeClr val="bg1"/>
+                </a:solidFill>
+              </a:rPr>
+              <a:t>When Do Drivers Matter</a:t>
+            </a:r>
+          </a:p>
+        </p:txBody>
+      </p:sp>
+      <p:sp>
+        <p:nvSpPr>
+          <p:cNvPr id="11" name="TextBox 10">
+            <a:extLst>
+              <a:ext uri="{FF2B5EF4-FFF2-40B4-BE49-F238E27FC236}">
+                <a16:creationId xmlns:a16="http://schemas.microsoft.com/office/drawing/2014/main" id="{41355400-6FEF-AD30-128B-DC3422E8C2B4}"/>
+              </a:ext>
+            </a:extLst>
+          </p:cNvPr>
+          <p:cNvSpPr txBox="1"/>
+          <p:nvPr/>
+        </p:nvSpPr>
+        <p:spPr>
+          <a:xfrm>
+            <a:off x="139613" y="1368962"/>
+            <a:ext cx="6706030" cy="4524315"/>
+          </a:xfrm>
+          <a:prstGeom prst="rect">
+            <a:avLst/>
+          </a:prstGeom>
+          <a:noFill/>
+        </p:spPr>
+        <p:txBody>
+          <a:bodyPr wrap="square">
+            <a:spAutoFit/>
+          </a:bodyPr>
+          <a:lstStyle/>
+          <a:p>
+            <a:r>
+              <a:rPr lang="en-US" sz="1600" b="1" dirty="0"/>
+              <a:t>Key Findings:</a:t>
+            </a:r>
+          </a:p>
+          <a:p>
+            <a:pPr marL="342900" indent="-342900">
+              <a:buFont typeface="Arial" panose="020B0604020202020204" pitchFamily="34" charset="0"/>
+              <a:buChar char="•"/>
+            </a:pPr>
+            <a:r>
+              <a:rPr lang="en-US" sz="1600" dirty="0"/>
+              <a:t>Hurricanes (wind exposure) have the strongest impact at lag 1 </a:t>
+            </a:r>
+          </a:p>
+          <a:p>
+            <a:pPr marL="342900" indent="-342900">
+              <a:buFont typeface="Arial" panose="020B0604020202020204" pitchFamily="34" charset="0"/>
+              <a:buChar char="•"/>
+            </a:pPr>
+            <a:r>
+              <a:rPr lang="en-US" sz="1600" dirty="0"/>
+              <a:t>Earthquake effects are both immediate and short-term persistent </a:t>
+            </a:r>
+          </a:p>
+          <a:p>
+            <a:pPr marL="342900" indent="-342900">
+              <a:buFont typeface="Arial" panose="020B0604020202020204" pitchFamily="34" charset="0"/>
+              <a:buChar char="•"/>
+            </a:pPr>
+            <a:r>
+              <a:rPr lang="en-US" sz="1600" dirty="0"/>
+              <a:t>Vulnerability (SVI) influences population change consistently over time </a:t>
+            </a:r>
+          </a:p>
+          <a:p>
+            <a:pPr marL="342900" indent="-342900">
+              <a:buFont typeface="Arial" panose="020B0604020202020204" pitchFamily="34" charset="0"/>
+              <a:buChar char="•"/>
+            </a:pPr>
+            <a:r>
+              <a:rPr lang="en-US" sz="1600" dirty="0"/>
+              <a:t>Economic variables contribute modest but stable effects </a:t>
+            </a:r>
+          </a:p>
+          <a:p>
+            <a:br>
+              <a:rPr lang="en-US" sz="1600" dirty="0"/>
+            </a:br>
+            <a:endParaRPr lang="en-US" sz="1600" dirty="0"/>
+          </a:p>
+          <a:p>
+            <a:endParaRPr lang="en-US" sz="1600" dirty="0"/>
+          </a:p>
+          <a:p>
+            <a:r>
+              <a:rPr lang="en-US" sz="1600" b="1" dirty="0"/>
+              <a:t>Interpretation:</a:t>
+            </a:r>
+          </a:p>
+          <a:p>
+            <a:pPr marL="342900" indent="-342900">
+              <a:buFont typeface="Arial" panose="020B0604020202020204" pitchFamily="34" charset="0"/>
+              <a:buChar char="•"/>
+            </a:pPr>
+            <a:r>
+              <a:rPr lang="en-US" sz="1600" dirty="0"/>
+              <a:t>Population responses to disasters are delayed, not immediate </a:t>
+            </a:r>
+          </a:p>
+          <a:p>
+            <a:pPr marL="342900" indent="-342900">
+              <a:buFont typeface="Arial" panose="020B0604020202020204" pitchFamily="34" charset="0"/>
+              <a:buChar char="•"/>
+            </a:pPr>
+            <a:r>
+              <a:rPr lang="en-US" sz="1600" dirty="0"/>
+              <a:t>Migration and recovery processes likely drive lagged effects </a:t>
+            </a:r>
+          </a:p>
+          <a:p>
+            <a:pPr marL="342900" indent="-342900">
+              <a:buFont typeface="Arial" panose="020B0604020202020204" pitchFamily="34" charset="0"/>
+              <a:buChar char="•"/>
+            </a:pPr>
+            <a:r>
+              <a:rPr lang="en-US" sz="1600" dirty="0"/>
+              <a:t>Structural factors shape baseline vulnerability across time </a:t>
+            </a:r>
+          </a:p>
+          <a:p>
+            <a:br>
+              <a:rPr lang="en-US" sz="1600" dirty="0"/>
+            </a:br>
+            <a:endParaRPr lang="en-US" sz="1600" dirty="0"/>
+          </a:p>
+          <a:p>
+            <a:endParaRPr lang="en-US" sz="1600" dirty="0"/>
+          </a:p>
+          <a:p>
+            <a:r>
+              <a:rPr lang="en-US" sz="1600" b="1" dirty="0"/>
+              <a:t>Key Insight: </a:t>
+            </a:r>
+            <a:r>
+              <a:rPr lang="en-US" sz="1600" dirty="0"/>
+              <a:t>Timing matters — not just magnitude</a:t>
+            </a:r>
+            <a:br>
+              <a:rPr lang="en-US" sz="1600" dirty="0"/>
+            </a:br>
+            <a:r>
+              <a:rPr lang="en-US" sz="1600" dirty="0"/>
+              <a:t>Population change is driven by </a:t>
+            </a:r>
+            <a:r>
+              <a:rPr lang="en-US" sz="1600" b="1" dirty="0"/>
+              <a:t>delayed responses to shocks and persistent structural conditions</a:t>
+            </a:r>
+            <a:endParaRPr lang="en-US" sz="1600" dirty="0"/>
+          </a:p>
+        </p:txBody>
+      </p:sp>
+      <p:pic>
+        <p:nvPicPr>
+          <p:cNvPr id="3" name="Picture 2">
+            <a:extLst>
+              <a:ext uri="{FF2B5EF4-FFF2-40B4-BE49-F238E27FC236}">
+                <a16:creationId xmlns:a16="http://schemas.microsoft.com/office/drawing/2014/main" id="{C1FD42D7-76D3-259B-08F9-14DCC8C5626D}"/>
+              </a:ext>
+            </a:extLst>
+          </p:cNvPr>
+          <p:cNvPicPr>
+            <a:picLocks noChangeAspect="1"/>
+          </p:cNvPicPr>
+          <p:nvPr/>
+        </p:nvPicPr>
+        <p:blipFill>
+          <a:blip r:embed="rId3">
+            <a:extLst>
+              <a:ext uri="{28A0092B-C50C-407E-A947-70E740481C1C}">
+                <a14:useLocalDpi xmlns:a14="http://schemas.microsoft.com/office/drawing/2010/main" val="0"/>
+              </a:ext>
+            </a:extLst>
+          </a:blip>
+          <a:stretch>
+            <a:fillRect/>
+          </a:stretch>
+        </p:blipFill>
+        <p:spPr>
+          <a:xfrm>
+            <a:off x="6637304" y="2444000"/>
+            <a:ext cx="5415083" cy="3757094"/>
+          </a:xfrm>
+          <a:prstGeom prst="rect">
+            <a:avLst/>
+          </a:prstGeom>
+        </p:spPr>
+      </p:pic>
+    </p:spTree>
+    <p:extLst>
+      <p:ext uri="{BB962C8B-B14F-4D97-AF65-F5344CB8AC3E}">
+        <p14:creationId xmlns:p14="http://schemas.microsoft.com/office/powerpoint/2010/main" val="3456856551"/>
+      </p:ext>
+    </p:extLst>
+  </p:cSld>
+  <p:clrMapOvr>
+    <a:masterClrMapping/>
+  </p:clrMapOvr>
+</p:sld>
+</file>
+
+<file path=ppt/slides/slide8.xml><?xml version="1.0" encoding="utf-8"?>
+<p:sld xmlns:a="http://schemas.openxmlformats.org/drawingml/2006/main" xmlns:r="http://schemas.openxmlformats.org/officeDocument/2006/relationships" xmlns:p="http://schemas.openxmlformats.org/presentationml/2006/main">
+  <p:cSld>
+    <p:spTree>
+      <p:nvGrpSpPr>
+        <p:cNvPr id="1" name="">
+          <a:extLst>
+            <a:ext uri="{FF2B5EF4-FFF2-40B4-BE49-F238E27FC236}">
               <a16:creationId xmlns:a16="http://schemas.microsoft.com/office/drawing/2014/main" id="{C6A2ACF3-8AD5-5B55-CC0F-B560A9E972E7}"/>
             </a:ext>
           </a:extLst>
@@ -19989,7 +20927,7 @@
 </p:sld>
 </file>
 
-<file path=ppt/slides/slide8.xml><?xml version="1.0" encoding="utf-8"?>
+<file path=ppt/slides/slide9.xml><?xml version="1.0" encoding="utf-8"?>
 <p:sld xmlns:a="http://schemas.openxmlformats.org/drawingml/2006/main" xmlns:r="http://schemas.openxmlformats.org/officeDocument/2006/relationships" xmlns:p="http://schemas.openxmlformats.org/presentationml/2006/main">
   <p:cSld>
     <p:spTree>
@@ -20289,310 +21227,6 @@
     <p:extLst>
       <p:ext uri="{BB962C8B-B14F-4D97-AF65-F5344CB8AC3E}">
         <p14:creationId xmlns:p14="http://schemas.microsoft.com/office/powerpoint/2010/main" val="2050642800"/>
-      </p:ext>
-    </p:extLst>
-  </p:cSld>
-  <p:clrMapOvr>
-    <a:masterClrMapping/>
-  </p:clrMapOvr>
-</p:sld>
-</file>
-
-<file path=ppt/slides/slide9.xml><?xml version="1.0" encoding="utf-8"?>
-<p:sld xmlns:a="http://schemas.openxmlformats.org/drawingml/2006/main" xmlns:r="http://schemas.openxmlformats.org/officeDocument/2006/relationships" xmlns:p="http://schemas.openxmlformats.org/presentationml/2006/main">
-  <p:cSld>
-    <p:spTree>
-      <p:nvGrpSpPr>
-        <p:cNvPr id="1" name="">
-          <a:extLst>
-            <a:ext uri="{FF2B5EF4-FFF2-40B4-BE49-F238E27FC236}">
-              <a16:creationId xmlns:a16="http://schemas.microsoft.com/office/drawing/2014/main" id="{7E0CB461-06C7-B3FE-2FD3-A6EAA2C2C6C6}"/>
-            </a:ext>
-          </a:extLst>
-        </p:cNvPr>
-        <p:cNvGrpSpPr/>
-        <p:nvPr/>
-      </p:nvGrpSpPr>
-      <p:grpSpPr>
-        <a:xfrm>
-          <a:off x="0" y="0"/>
-          <a:ext cx="0" cy="0"/>
-          <a:chOff x="0" y="0"/>
-          <a:chExt cx="0" cy="0"/>
-        </a:xfrm>
-      </p:grpSpPr>
-      <p:sp>
-        <p:nvSpPr>
-          <p:cNvPr id="4" name="Rectangle 3">
-            <a:extLst>
-              <a:ext uri="{FF2B5EF4-FFF2-40B4-BE49-F238E27FC236}">
-                <a16:creationId xmlns:a16="http://schemas.microsoft.com/office/drawing/2014/main" id="{46AFF467-EA34-A1E1-7D27-49257098751A}"/>
-              </a:ext>
-            </a:extLst>
-          </p:cNvPr>
-          <p:cNvSpPr/>
-          <p:nvPr/>
-        </p:nvSpPr>
-        <p:spPr>
-          <a:xfrm>
-            <a:off x="0" y="196343"/>
-            <a:ext cx="7199290" cy="1007423"/>
-          </a:xfrm>
-          <a:prstGeom prst="rect">
-            <a:avLst/>
-          </a:prstGeom>
-          <a:solidFill>
-            <a:srgbClr val="CC0033"/>
-          </a:solidFill>
-          <a:ln>
-            <a:noFill/>
-          </a:ln>
-        </p:spPr>
-        <p:style>
-          <a:lnRef idx="1">
-            <a:schemeClr val="accent1"/>
-          </a:lnRef>
-          <a:fillRef idx="3">
-            <a:schemeClr val="accent1"/>
-          </a:fillRef>
-          <a:effectRef idx="2">
-            <a:schemeClr val="accent1"/>
-          </a:effectRef>
-          <a:fontRef idx="minor">
-            <a:schemeClr val="lt1"/>
-          </a:fontRef>
-        </p:style>
-        <p:txBody>
-          <a:bodyPr rtlCol="0" anchor="ctr"/>
-          <a:lstStyle/>
-          <a:p>
-            <a:pPr algn="ctr"/>
-            <a:endParaRPr lang="en-US" dirty="0">
-              <a:solidFill>
-                <a:schemeClr val="accent1"/>
-              </a:solidFill>
-            </a:endParaRPr>
-          </a:p>
-        </p:txBody>
-      </p:sp>
-      <p:sp>
-        <p:nvSpPr>
-          <p:cNvPr id="5" name="Title 10">
-            <a:extLst>
-              <a:ext uri="{FF2B5EF4-FFF2-40B4-BE49-F238E27FC236}">
-                <a16:creationId xmlns:a16="http://schemas.microsoft.com/office/drawing/2014/main" id="{1C9245BE-7F46-5541-F240-56BA0A3CBFE3}"/>
-              </a:ext>
-            </a:extLst>
-          </p:cNvPr>
-          <p:cNvSpPr txBox="1">
-            <a:spLocks/>
-          </p:cNvSpPr>
-          <p:nvPr/>
-        </p:nvSpPr>
-        <p:spPr>
-          <a:xfrm>
-            <a:off x="459357" y="361539"/>
-            <a:ext cx="6546750" cy="719563"/>
-          </a:xfrm>
-          <a:prstGeom prst="rect">
-            <a:avLst/>
-          </a:prstGeom>
-        </p:spPr>
-        <p:txBody>
-          <a:bodyPr anchor="ctr" anchorCtr="0">
-            <a:noAutofit/>
-          </a:bodyPr>
-          <a:lstStyle>
-            <a:lvl1pPr algn="ctr" defTabSz="457200" rtl="0" eaLnBrk="1" latinLnBrk="0" hangingPunct="1">
-              <a:spcBef>
-                <a:spcPct val="0"/>
-              </a:spcBef>
-              <a:buNone/>
-              <a:defRPr sz="4400" kern="1200">
-                <a:solidFill>
-                  <a:schemeClr val="tx1"/>
-                </a:solidFill>
-                <a:latin typeface="+mj-lt"/>
-                <a:ea typeface="+mj-ea"/>
-                <a:cs typeface="+mj-cs"/>
-              </a:defRPr>
-            </a:lvl1pPr>
-          </a:lstStyle>
-          <a:p>
-            <a:pPr lvl="0"/>
-            <a:r>
-              <a:rPr lang="en-US" sz="3200" b="1" dirty="0">
-                <a:solidFill>
-                  <a:schemeClr val="bg1"/>
-                </a:solidFill>
-              </a:rPr>
-              <a:t>Structural Patterns </a:t>
-            </a:r>
-          </a:p>
-          <a:p>
-            <a:pPr lvl="0"/>
-            <a:r>
-              <a:rPr lang="en-US" sz="3200" b="1" dirty="0">
-                <a:solidFill>
-                  <a:schemeClr val="bg1"/>
-                </a:solidFill>
-              </a:rPr>
-              <a:t>(Beyond Prediction)</a:t>
-            </a:r>
-          </a:p>
-        </p:txBody>
-      </p:sp>
-      <p:sp>
-        <p:nvSpPr>
-          <p:cNvPr id="11" name="TextBox 10">
-            <a:extLst>
-              <a:ext uri="{FF2B5EF4-FFF2-40B4-BE49-F238E27FC236}">
-                <a16:creationId xmlns:a16="http://schemas.microsoft.com/office/drawing/2014/main" id="{5F60B027-7280-1B08-F112-1AB1AFF3FADD}"/>
-              </a:ext>
-            </a:extLst>
-          </p:cNvPr>
-          <p:cNvSpPr txBox="1"/>
-          <p:nvPr/>
-        </p:nvSpPr>
-        <p:spPr>
-          <a:xfrm>
-            <a:off x="139613" y="1368962"/>
-            <a:ext cx="9560053" cy="4708981"/>
-          </a:xfrm>
-          <a:prstGeom prst="rect">
-            <a:avLst/>
-          </a:prstGeom>
-          <a:noFill/>
-        </p:spPr>
-        <p:txBody>
-          <a:bodyPr wrap="square">
-            <a:spAutoFit/>
-          </a:bodyPr>
-          <a:lstStyle/>
-          <a:p>
-            <a:r>
-              <a:rPr lang="en-US" sz="2000" b="1" dirty="0"/>
-              <a:t>What emerges</a:t>
-            </a:r>
-          </a:p>
-          <a:p>
-            <a:pPr marL="285750" indent="-285750">
-              <a:buFont typeface="Arial" panose="020B0604020202020204" pitchFamily="34" charset="0"/>
-              <a:buChar char="•"/>
-            </a:pPr>
-            <a:r>
-              <a:rPr lang="en-US" sz="2000" dirty="0"/>
-              <a:t>Distinct municipal typologies</a:t>
-            </a:r>
-          </a:p>
-          <a:p>
-            <a:pPr marL="285750" indent="-285750">
-              <a:buFont typeface="Arial" panose="020B0604020202020204" pitchFamily="34" charset="0"/>
-              <a:buChar char="•"/>
-            </a:pPr>
-            <a:r>
-              <a:rPr lang="en-US" sz="2000" dirty="0"/>
-              <a:t>Clear regional clustering</a:t>
-            </a:r>
-            <a:br>
-              <a:rPr lang="en-US" sz="2000" dirty="0"/>
-            </a:br>
-            <a:endParaRPr lang="en-US" sz="2000" dirty="0"/>
-          </a:p>
-          <a:p>
-            <a:r>
-              <a:rPr lang="en-US" sz="2000" b="1" dirty="0"/>
-              <a:t>Key result</a:t>
-            </a:r>
-          </a:p>
-          <a:p>
-            <a:pPr marL="285750" indent="-285750">
-              <a:buFont typeface="Arial" panose="020B0604020202020204" pitchFamily="34" charset="0"/>
-              <a:buChar char="•"/>
-            </a:pPr>
-            <a:r>
-              <a:rPr lang="en-US" sz="2000" dirty="0"/>
-              <a:t>Patterns are stable and spatially coherent</a:t>
-            </a:r>
-          </a:p>
-          <a:p>
-            <a:pPr marL="285750" indent="-285750">
-              <a:buFont typeface="Arial" panose="020B0604020202020204" pitchFamily="34" charset="0"/>
-              <a:buChar char="•"/>
-            </a:pPr>
-            <a:r>
-              <a:rPr lang="en-US" sz="2000" dirty="0"/>
-              <a:t>Similar municipalities cluster together </a:t>
-            </a:r>
-          </a:p>
-          <a:p>
-            <a:pPr marL="285750" indent="-285750">
-              <a:buFont typeface="Arial" panose="020B0604020202020204" pitchFamily="34" charset="0"/>
-              <a:buChar char="•"/>
-            </a:pPr>
-            <a:r>
-              <a:rPr lang="en-US" sz="2000" dirty="0"/>
-              <a:t>Neighboring regions share structural characteristics </a:t>
-            </a:r>
-          </a:p>
-          <a:p>
-            <a:pPr marL="285750" indent="-285750">
-              <a:buFont typeface="Arial" panose="020B0604020202020204" pitchFamily="34" charset="0"/>
-              <a:buChar char="•"/>
-            </a:pPr>
-            <a:r>
-              <a:rPr lang="en-US" sz="2000" dirty="0"/>
-              <a:t>Results are consistent across specifications </a:t>
-            </a:r>
-          </a:p>
-          <a:p>
-            <a:br>
-              <a:rPr lang="en-US" sz="2000" dirty="0"/>
-            </a:br>
-            <a:endParaRPr lang="en-US" sz="2000" dirty="0"/>
-          </a:p>
-          <a:p>
-            <a:r>
-              <a:rPr lang="en-US" sz="2000" b="1" dirty="0"/>
-              <a:t>Interpretation</a:t>
-            </a:r>
-          </a:p>
-          <a:p>
-            <a:pPr marL="285750" indent="-285750">
-              <a:buFont typeface="Arial" panose="020B0604020202020204" pitchFamily="34" charset="0"/>
-              <a:buChar char="•"/>
-            </a:pPr>
-            <a:r>
-              <a:rPr lang="en-US" sz="2000" dirty="0"/>
-              <a:t>Population dynamics are spatially structured, not random</a:t>
-            </a:r>
-          </a:p>
-          <a:p>
-            <a:pPr marL="285750" indent="-285750">
-              <a:buFont typeface="Arial" panose="020B0604020202020204" pitchFamily="34" charset="0"/>
-              <a:buChar char="•"/>
-            </a:pPr>
-            <a:r>
-              <a:rPr lang="en-US" sz="2000" dirty="0"/>
-              <a:t>Decline is concentrated in specific regions </a:t>
-            </a:r>
-          </a:p>
-          <a:p>
-            <a:pPr marL="285750" indent="-285750">
-              <a:buFont typeface="Arial" panose="020B0604020202020204" pitchFamily="34" charset="0"/>
-              <a:buChar char="•"/>
-            </a:pPr>
-            <a:r>
-              <a:rPr lang="en-US" sz="2000" dirty="0"/>
-              <a:t>Vulnerability and economic conditions align geographically</a:t>
-            </a:r>
-          </a:p>
-        </p:txBody>
-      </p:sp>
-    </p:spTree>
-    <p:extLst>
-      <p:ext uri="{BB962C8B-B14F-4D97-AF65-F5344CB8AC3E}">
-        <p14:creationId xmlns:p14="http://schemas.microsoft.com/office/powerpoint/2010/main" val="628415208"/>
       </p:ext>
     </p:extLst>
   </p:cSld>
@@ -21394,14 +22028,6 @@
 </file>
 
 <file path=customXml/item1.xml><?xml version="1.0" encoding="utf-8"?>
-<p:properties xmlns:p="http://schemas.microsoft.com/office/2006/metadata/properties" xmlns:xsi="http://www.w3.org/2001/XMLSchema-instance" xmlns:pc="http://schemas.microsoft.com/office/infopath/2007/PartnerControls">
-  <documentManagement>
-    <_activity xmlns="11e45801-bee2-4eee-abb6-7fc01a896634" xsi:nil="true"/>
-  </documentManagement>
-</p:properties>
-</file>
-
-<file path=customXml/item2.xml><?xml version="1.0" encoding="utf-8"?>
 <ct:contentTypeSchema xmlns:ct="http://schemas.microsoft.com/office/2006/metadata/contentType" xmlns:ma="http://schemas.microsoft.com/office/2006/metadata/properties/metaAttributes" ct:_="" ma:_="" ma:contentTypeName="Document" ma:contentTypeID="0x01010015021A5DC4BEF54E90B3A7E0D30B82FD" ma:contentTypeVersion="5" ma:contentTypeDescription="Create a new document." ma:contentTypeScope="" ma:versionID="0b09cb170d6a15113edb6f479f6ecd10">
   <xsd:schema xmlns:xsd="http://www.w3.org/2001/XMLSchema" xmlns:xs="http://www.w3.org/2001/XMLSchema" xmlns:p="http://schemas.microsoft.com/office/2006/metadata/properties" xmlns:ns3="11e45801-bee2-4eee-abb6-7fc01a896634" targetNamespace="http://schemas.microsoft.com/office/2006/metadata/properties" ma:root="true" ma:fieldsID="c9b1b393770a16940206f9bb69539431" ns3:_="">
     <xsd:import namespace="11e45801-bee2-4eee-abb6-7fc01a896634"/>
@@ -21551,7 +22177,7 @@
 </ct:contentTypeSchema>
 </file>
 
-<file path=customXml/item3.xml><?xml version="1.0" encoding="utf-8"?>
+<file path=customXml/item2.xml><?xml version="1.0" encoding="utf-8"?>
 <?mso-contentType ?>
 <FormTemplates xmlns="http://schemas.microsoft.com/sharepoint/v3/contenttype/forms">
   <Display>DocumentLibraryForm</Display>
@@ -21560,23 +22186,15 @@
 </FormTemplates>
 </file>
 
-<file path=customXml/itemProps1.xml><?xml version="1.0" encoding="utf-8"?>
-<ds:datastoreItem xmlns:ds="http://schemas.openxmlformats.org/officeDocument/2006/customXml" ds:itemID="{1EFFF01E-6DF4-4530-B663-FF4BD91444A6}">
-  <ds:schemaRefs>
-    <ds:schemaRef ds:uri="11e45801-bee2-4eee-abb6-7fc01a896634"/>
-    <ds:schemaRef ds:uri="http://schemas.microsoft.com/office/2006/documentManagement/types"/>
-    <ds:schemaRef ds:uri="http://www.w3.org/XML/1998/namespace"/>
-    <ds:schemaRef ds:uri="http://schemas.microsoft.com/office/2006/metadata/properties"/>
-    <ds:schemaRef ds:uri="http://purl.org/dc/terms/"/>
-    <ds:schemaRef ds:uri="http://purl.org/dc/elements/1.1/"/>
-    <ds:schemaRef ds:uri="http://schemas.microsoft.com/office/infopath/2007/PartnerControls"/>
-    <ds:schemaRef ds:uri="http://schemas.openxmlformats.org/package/2006/metadata/core-properties"/>
-    <ds:schemaRef ds:uri="http://purl.org/dc/dcmitype/"/>
-  </ds:schemaRefs>
-</ds:datastoreItem>
+<file path=customXml/item3.xml><?xml version="1.0" encoding="utf-8"?>
+<p:properties xmlns:p="http://schemas.microsoft.com/office/2006/metadata/properties" xmlns:xsi="http://www.w3.org/2001/XMLSchema-instance" xmlns:pc="http://schemas.microsoft.com/office/infopath/2007/PartnerControls">
+  <documentManagement>
+    <_activity xmlns="11e45801-bee2-4eee-abb6-7fc01a896634" xsi:nil="true"/>
+  </documentManagement>
+</p:properties>
 </file>
 
-<file path=customXml/itemProps2.xml><?xml version="1.0" encoding="utf-8"?>
+<file path=customXml/itemProps1.xml><?xml version="1.0" encoding="utf-8"?>
 <ds:datastoreItem xmlns:ds="http://schemas.openxmlformats.org/officeDocument/2006/customXml" ds:itemID="{CB7AAD6B-2CD1-4FD9-A228-72630DF2E75E}">
   <ds:schemaRefs>
     <ds:schemaRef ds:uri="http://schemas.microsoft.com/office/2006/metadata/contentType"/>
@@ -21594,10 +22212,26 @@
 </ds:datastoreItem>
 </file>
 
-<file path=customXml/itemProps3.xml><?xml version="1.0" encoding="utf-8"?>
+<file path=customXml/itemProps2.xml><?xml version="1.0" encoding="utf-8"?>
 <ds:datastoreItem xmlns:ds="http://schemas.openxmlformats.org/officeDocument/2006/customXml" ds:itemID="{B94EBF72-05B3-4092-B058-100DE54983B2}">
   <ds:schemaRefs>
     <ds:schemaRef ds:uri="http://schemas.microsoft.com/sharepoint/v3/contenttype/forms"/>
   </ds:schemaRefs>
 </ds:datastoreItem>
+</file>
+
+<file path=customXml/itemProps3.xml><?xml version="1.0" encoding="utf-8"?>
+<ds:datastoreItem xmlns:ds="http://schemas.openxmlformats.org/officeDocument/2006/customXml" ds:itemID="{1EFFF01E-6DF4-4530-B663-FF4BD91444A6}">
+  <ds:schemaRefs>
+    <ds:schemaRef ds:uri="11e45801-bee2-4eee-abb6-7fc01a896634"/>
+    <ds:schemaRef ds:uri="http://schemas.microsoft.com/office/2006/documentManagement/types"/>
+    <ds:schemaRef ds:uri="http://www.w3.org/XML/1998/namespace"/>
+    <ds:schemaRef ds:uri="http://schemas.microsoft.com/office/2006/metadata/properties"/>
+    <ds:schemaRef ds:uri="http://purl.org/dc/terms/"/>
+    <ds:schemaRef ds:uri="http://purl.org/dc/elements/1.1/"/>
+    <ds:schemaRef ds:uri="http://schemas.microsoft.com/office/infopath/2007/PartnerControls"/>
+    <ds:schemaRef ds:uri="http://schemas.openxmlformats.org/package/2006/metadata/core-properties"/>
+    <ds:schemaRef ds:uri="http://purl.org/dc/dcmitype/"/>
+  </ds:schemaRefs>
+</ds:datastoreItem>
 </file>
</xml_diff>